<commit_message>
BP v31: bring personal agents back, concretely
Cover line 'Before a personal agent is trusted, it practices here' and a
personal-agent page after the data business: Sep 2026 signals (Muse,
Dots, Instinct, a $200 mis-booking), what we open, how we charge, data
rules and a milestone. Clone sources are read before any page is built.

Co-Authored-By: Claude Opus 5.5 <noreply@anthropic.com>
Claude-Session: https://claude.ai/code/session_01EKqGwTA92C8Wo4e47t73NN
</commit_message>
<xml_diff>
--- a/SimReal-BP-v31.pptx
+++ b/SimReal-BP-v31.pptx
@@ -18,6 +18,7 @@
     <p:sldId id="275" r:id="rId21"/>
     <p:sldId id="264" r:id="rId10"/>
     <p:sldId id="265" r:id="rId11"/>
+    <p:sldId id="279" r:id="rId46"/>
     <p:sldId id="259" r:id="rId5"/>
     <p:sldId id="269" r:id="rId15"/>
     <p:sldId id="270" r:id="rId16"/>
@@ -27,7 +28,7 @@
     <p:sldId id="268" r:id="rId14"/>
     <p:sldId id="272" r:id="rId18"/>
     <p:sldId id="278" r:id="rId45"/>
-    <p:sldId id="279" r:id="rId46"/>
+    <p:sldId id="280" r:id="rId47"/>
     <p:sldId id="273" r:id="rId19"/>
     <p:sldId id="274" r:id="rId20"/>
     <p:sldId id="276" r:id="rId22"/>
@@ -6107,7 +6108,7 @@
                 <a:cs typeface="Newsreader"/>
                 <a:sym typeface="Newsreader"/>
               </a:rPr>
-              <a:t>从交易开始：用可复现的结算给Agent打分、训练</a:t>
+              <a:t>个人Agent被托付之前，先在这里练过</a:t>
             </a:r>
           </a:p>
         </p:txBody>
@@ -6156,7 +6157,7 @@
                 <a:cs typeface="Instrument Sans"/>
                 <a:sym typeface="Instrument Sans"/>
               </a:rPr>
-              <a:t>面向AI实验室的金融与专业领域训练环境与数据</a:t>
+              <a:t>从交易开始：面向AI实验室与个人Agent的训练环境与数据</a:t>
             </a:r>
           </a:p>
         </p:txBody>
@@ -8540,7 +8541,7 @@
                 <a:cs typeface="IBM Plex Mono"/>
                 <a:sym typeface="IBM Plex Mono"/>
               </a:rPr>
-              <a:t>15</a:t>
+              <a:t>16</a:t>
             </a:r>
           </a:p>
         </p:txBody>
@@ -10912,7 +10913,7 @@
                 <a:cs typeface="IBM Plex Mono"/>
                 <a:sym typeface="IBM Plex Mono"/>
               </a:rPr>
-              <a:t>15</a:t>
+              <a:t>16</a:t>
             </a:r>
           </a:p>
         </p:txBody>
@@ -11129,7 +11130,7 @@
                 <a:cs typeface="IBM Plex Mono"/>
                 <a:sym typeface="IBM Plex Mono"/>
               </a:rPr>
-              <a:t>16</a:t>
+              <a:t>17</a:t>
             </a:r>
           </a:p>
         </p:txBody>
@@ -13727,7 +13728,7 @@
                 <a:cs typeface="IBM Plex Mono"/>
                 <a:sym typeface="IBM Plex Mono"/>
               </a:rPr>
-              <a:t>16</a:t>
+              <a:t>17</a:t>
             </a:r>
           </a:p>
         </p:txBody>
@@ -14160,7 +14161,7 @@
                 <a:cs typeface="IBM Plex Mono"/>
                 <a:sym typeface="IBM Plex Mono"/>
               </a:rPr>
-              <a:t>17</a:t>
+              <a:t>18</a:t>
             </a:r>
           </a:p>
         </p:txBody>
@@ -15305,7 +15306,7 @@
                 <a:cs typeface="IBM Plex Mono"/>
                 <a:sym typeface="IBM Plex Mono"/>
               </a:rPr>
-              <a:t>17</a:t>
+              <a:t>18</a:t>
             </a:r>
           </a:p>
         </p:txBody>
@@ -15414,7 +15415,7 @@
                 <a:cs typeface="IBM Plex Mono"/>
                 <a:sym typeface="IBM Plex Mono"/>
               </a:rPr>
-              <a:t>12</a:t>
+              <a:t>13</a:t>
             </a:r>
           </a:p>
         </p:txBody>
@@ -17616,7 +17617,7 @@
                 <a:cs typeface="IBM Plex Mono"/>
                 <a:sym typeface="IBM Plex Mono"/>
               </a:rPr>
-              <a:t>12</a:t>
+              <a:t>13</a:t>
             </a:r>
           </a:p>
         </p:txBody>
@@ -17725,7 +17726,7 @@
                 <a:cs typeface="IBM Plex Mono"/>
                 <a:sym typeface="IBM Plex Mono"/>
               </a:rPr>
-              <a:t>13</a:t>
+              <a:t>14</a:t>
             </a:r>
           </a:p>
         </p:txBody>
@@ -19708,7 +19709,7 @@
                 <a:cs typeface="IBM Plex Mono"/>
                 <a:sym typeface="IBM Plex Mono"/>
               </a:rPr>
-              <a:t>13</a:t>
+              <a:t>14</a:t>
             </a:r>
           </a:p>
         </p:txBody>
@@ -19817,7 +19818,7 @@
                 <a:cs typeface="IBM Plex Mono"/>
                 <a:sym typeface="IBM Plex Mono"/>
               </a:rPr>
-              <a:t>14</a:t>
+              <a:t>15</a:t>
             </a:r>
           </a:p>
         </p:txBody>
@@ -21301,7 +21302,7 @@
                 <a:cs typeface="IBM Plex Mono"/>
                 <a:sym typeface="IBM Plex Mono"/>
               </a:rPr>
-              <a:t>14</a:t>
+              <a:t>15</a:t>
             </a:r>
           </a:p>
         </p:txBody>
@@ -21410,7 +21411,7 @@
                 <a:cs typeface="IBM Plex Mono"/>
                 <a:sym typeface="IBM Plex Mono"/>
               </a:rPr>
-              <a:t>18</a:t>
+              <a:t>19</a:t>
             </a:r>
           </a:p>
         </p:txBody>
@@ -23635,7 +23636,7 @@
                 <a:cs typeface="IBM Plex Mono"/>
                 <a:sym typeface="IBM Plex Mono"/>
               </a:rPr>
-              <a:t>18</a:t>
+              <a:t>19</a:t>
             </a:r>
           </a:p>
         </p:txBody>
@@ -23744,7 +23745,7 @@
                 <a:cs typeface="IBM Plex Mono"/>
                 <a:sym typeface="IBM Plex Mono"/>
               </a:rPr>
-              <a:t>19</a:t>
+              <a:t>20</a:t>
             </a:r>
           </a:p>
         </p:txBody>
@@ -26651,7 +26652,7 @@
                 <a:cs typeface="IBM Plex Mono"/>
                 <a:sym typeface="IBM Plex Mono"/>
               </a:rPr>
-              <a:t>19</a:t>
+              <a:t>20</a:t>
             </a:r>
           </a:p>
         </p:txBody>
@@ -27740,6 +27741,32 @@
               <a:t>卖给实验室：环境授权、Agent轨迹、评测数据</a:t>
             </a:r>
           </a:p>
+          <a:p>
+            <a:pPr marL="0" marR="0" lvl="0" indent="0" algn="l" rtl="0">
+              <a:lnSpc>
+                <a:spcPct val="114999"/>
+              </a:lnSpc>
+              <a:spcBef>
+                <a:spcPts val="0"/>
+              </a:spcBef>
+              <a:spcAft>
+                <a:spcPts val="0"/>
+              </a:spcAft>
+              <a:buNone/>
+            </a:pPr>
+            <a:r>
+              <a:rPr lang="zh-CN" sz="1100" b="0" i="0" u="none" strike="noStrike" cap="none">
+                <a:solidFill>
+                  <a:srgbClr val="33322F"/>
+                </a:solidFill>
+                <a:latin typeface="Instrument Sans"/>
+                <a:ea typeface="Instrument Sans"/>
+                <a:cs typeface="Instrument Sans"/>
+                <a:sym typeface="Instrument Sans"/>
+              </a:rPr>
+              <a:t>下一步：向个人Agent开放练习</a:t>
+            </a:r>
+          </a:p>
         </p:txBody>
       </p:sp>
       <p:sp>
@@ -33292,7 +33319,7 @@
                 <a:cs typeface="Instrument Sans"/>
                 <a:sym typeface="Instrument Sans"/>
               </a:rPr>
-              <a:t>Instinct：</a:t>
+              <a:t>个人Agent：</a:t>
             </a:r>
             <a:r>
               <a:rPr lang="zh-CN" sz="850" b="0" i="0" u="none" strike="noStrike" cap="none">
@@ -33304,7 +33331,7 @@
                 <a:cs typeface="Instrument Sans"/>
                 <a:sym typeface="Instrument Sans"/>
               </a:rPr>
-              <a:t>创始人Noah Shinn（Invest Like the Best播客，2026年9月）：</a:t>
+              <a:t>Meta Muse（2026年9月8日上线，9月18日登顶美国App Store；</a:t>
             </a:r>
             <a:br>
               <a:rPr lang="zh-CN" sz="850"/>
@@ -33319,7 +33346,75 @@
                 <a:cs typeface="Instrument Sans"/>
                 <a:sym typeface="Instrument Sans"/>
               </a:rPr>
-              <a:t>年交易额10亿美元以上，约一半为旅行；路透社（2026年9月28日）：估值100亿美元</a:t>
+              <a:t>TechCrunch、Business Insider）；OpenAI Dots（DevDay，2026年9月29日；The Verge、CNBC）</a:t>
+            </a:r>
+          </a:p>
+          <a:p>
+            <a:pPr marL="0" marR="0" lvl="0" indent="0" algn="l" rtl="0">
+              <a:lnSpc>
+                <a:spcPct val="110000"/>
+              </a:lnSpc>
+              <a:spcBef>
+                <a:spcPts val="400"/>
+              </a:spcBef>
+              <a:spcAft>
+                <a:spcPts val="0"/>
+              </a:spcAft>
+              <a:buNone/>
+            </a:pPr>
+            <a:r>
+              <a:rPr lang="zh-CN" sz="850" b="1" i="0" u="none" strike="noStrike" cap="none">
+                <a:solidFill>
+                  <a:srgbClr val="111110"/>
+                </a:solidFill>
+                <a:latin typeface="Instrument Sans"/>
+                <a:ea typeface="Instrument Sans"/>
+                <a:cs typeface="Instrument Sans"/>
+                <a:sym typeface="Instrument Sans"/>
+              </a:rPr>
+              <a:t>Instinct：</a:t>
+            </a:r>
+            <a:r>
+              <a:rPr lang="zh-CN" sz="850" b="0" i="0" u="none" strike="noStrike" cap="none">
+                <a:solidFill>
+                  <a:srgbClr val="33322F"/>
+                </a:solidFill>
+                <a:latin typeface="Instrument Sans"/>
+                <a:ea typeface="Instrument Sans"/>
+                <a:cs typeface="Instrument Sans"/>
+                <a:sym typeface="Instrument Sans"/>
+              </a:rPr>
+              <a:t>创始人Noah Shinn（Invest Like the Best播客，2026年9月）：年交易额10亿美元以上；</a:t>
+            </a:r>
+            <a:br>
+              <a:rPr lang="zh-CN" sz="850"/>
+            </a:br>
+            <a:r>
+              <a:rPr lang="zh-CN" sz="850" b="0" i="0" u="none" strike="noStrike" cap="none">
+                <a:solidFill>
+                  <a:srgbClr val="33322F"/>
+                </a:solidFill>
+                <a:latin typeface="Instrument Sans"/>
+                <a:ea typeface="Instrument Sans"/>
+                <a:cs typeface="Instrument Sans"/>
+                <a:sym typeface="Instrument Sans"/>
+              </a:rPr>
+              <a:t>路透社（2026年9月28日）：估值100亿美元，8月26日为25亿美元；</a:t>
+            </a:r>
+            <a:br>
+              <a:rPr lang="zh-CN" sz="850"/>
+            </a:br>
+            <a:r>
+              <a:rPr lang="zh-CN" sz="850" b="0" i="0" u="none" strike="noStrike" cap="none">
+                <a:solidFill>
+                  <a:srgbClr val="33322F"/>
+                </a:solidFill>
+                <a:latin typeface="Instrument Sans"/>
+                <a:ea typeface="Instrument Sans"/>
+                <a:cs typeface="Instrument Sans"/>
+                <a:sym typeface="Instrument Sans"/>
+              </a:rPr>
+              <a:t>《大西洋月刊》、CNN（2026年9月）：擅自订位致用户被收200美元取消费</a:t>
             </a:r>
           </a:p>
           <a:p>
@@ -35586,7 +35681,7 @@
                 <a:cs typeface="IBM Plex Mono"/>
                 <a:sym typeface="IBM Plex Mono"/>
               </a:rPr>
-              <a:t>20</a:t>
+              <a:t>11</a:t>
             </a:r>
           </a:p>
         </p:txBody>
@@ -35674,6 +35769,18 @@
               <a:t>   </a:t>
             </a:r>
             <a:r>
+              <a:rPr lang="zh-CN" sz="850" b="1" i="0" u="none" strike="noStrike" cap="none">
+                <a:solidFill>
+                  <a:srgbClr val="C2410C"/>
+                </a:solidFill>
+                <a:latin typeface="Instrument Sans"/>
+                <a:ea typeface="Instrument Sans"/>
+                <a:cs typeface="Instrument Sans"/>
+                <a:sym typeface="Instrument Sans"/>
+              </a:rPr>
+              <a:t>我们的答案</a:t>
+            </a:r>
+            <a:r>
               <a:rPr lang="zh-CN" sz="850" b="0" i="0" u="none" strike="noStrike" cap="none">
                 <a:solidFill>
                   <a:srgbClr val="9A978F"/>
@@ -35683,7 +35790,7 @@
                 <a:cs typeface="Instrument Sans"/>
                 <a:sym typeface="Instrument Sans"/>
               </a:rPr>
-              <a:t>我们的答案</a:t>
+              <a:t>   </a:t>
             </a:r>
             <a:r>
               <a:rPr lang="zh-CN" sz="850" b="0" i="0" u="none" strike="noStrike" cap="none">
@@ -35695,6 +35802,18 @@
                 <a:cs typeface="Instrument Sans"/>
                 <a:sym typeface="Instrument Sans"/>
               </a:rPr>
+              <a:t>市场与竞争</a:t>
+            </a:r>
+            <a:r>
+              <a:rPr lang="zh-CN" sz="850" b="0" i="0" u="none" strike="noStrike" cap="none">
+                <a:solidFill>
+                  <a:srgbClr val="9A978F"/>
+                </a:solidFill>
+                <a:latin typeface="Instrument Sans"/>
+                <a:ea typeface="Instrument Sans"/>
+                <a:cs typeface="Instrument Sans"/>
+                <a:sym typeface="Instrument Sans"/>
+              </a:rPr>
               <a:t>   </a:t>
             </a:r>
             <a:r>
@@ -35707,7 +35826,7 @@
                 <a:cs typeface="Instrument Sans"/>
                 <a:sym typeface="Instrument Sans"/>
               </a:rPr>
-              <a:t>市场与竞争</a:t>
+              <a:t>商业与进展</a:t>
             </a:r>
             <a:r>
               <a:rPr lang="zh-CN" sz="850" b="0" i="0" u="none" strike="noStrike" cap="none">
@@ -35725,30 +35844,6 @@
               <a:rPr lang="zh-CN" sz="850" b="0" i="0" u="none" strike="noStrike" cap="none">
                 <a:solidFill>
                   <a:srgbClr val="9A978F"/>
-                </a:solidFill>
-                <a:latin typeface="Instrument Sans"/>
-                <a:ea typeface="Instrument Sans"/>
-                <a:cs typeface="Instrument Sans"/>
-                <a:sym typeface="Instrument Sans"/>
-              </a:rPr>
-              <a:t>商业与进展</a:t>
-            </a:r>
-            <a:r>
-              <a:rPr lang="zh-CN" sz="850" b="0" i="0" u="none" strike="noStrike" cap="none">
-                <a:solidFill>
-                  <a:srgbClr val="9A978F"/>
-                </a:solidFill>
-                <a:latin typeface="Instrument Sans"/>
-                <a:ea typeface="Instrument Sans"/>
-                <a:cs typeface="Instrument Sans"/>
-                <a:sym typeface="Instrument Sans"/>
-              </a:rPr>
-              <a:t>   </a:t>
-            </a:r>
-            <a:r>
-              <a:rPr lang="zh-CN" sz="850" b="1" i="0" u="none" strike="noStrike" cap="none">
-                <a:solidFill>
-                  <a:srgbClr val="C2410C"/>
                 </a:solidFill>
                 <a:latin typeface="Instrument Sans"/>
                 <a:ea typeface="Instrument Sans"/>
@@ -35804,7 +35899,7 @@
                 <a:cs typeface="Newsreader"/>
                 <a:sym typeface="Newsreader"/>
               </a:rPr>
-              <a:t>风险与对策</a:t>
+              <a:t>下一步 · 个人Agent</a:t>
             </a:r>
           </a:p>
         </p:txBody>
@@ -35853,7 +35948,7 @@
                 <a:cs typeface="Newsreader"/>
                 <a:sym typeface="Newsreader"/>
               </a:rPr>
-              <a:t>把风险写在前面：</a:t>
+              <a:t>一个Agent在替人做事之前，</a:t>
             </a:r>
             <a:r>
               <a:rPr lang="zh-CN" sz="1600" b="0" i="0" u="none" strike="noStrike" cap="none">
@@ -35865,7 +35960,7 @@
                 <a:cs typeface="Newsreader"/>
                 <a:sym typeface="Newsreader"/>
               </a:rPr>
-              <a:t>每一条都有对应的验证节点</a:t>
+              <a:t>需要先在足够真实的地方练过</a:t>
             </a:r>
           </a:p>
         </p:txBody>
@@ -35873,68 +35968,39 @@
       <p:sp>
         <p:nvSpPr>
           <p:cNvPr id="5005" name="SimReal 5005"/>
-          <p:cNvSpPr/>
-          <p:nvPr/>
-        </p:nvSpPr>
-        <p:spPr>
-          <a:xfrm>
-            <a:off x="548640" y="1517904"/>
-            <a:ext cx="11091672" cy="9144"/>
-          </a:xfrm>
-          <a:prstGeom prst="rect">
-            <a:avLst/>
-          </a:prstGeom>
-          <a:solidFill>
-            <a:srgbClr val="111110"/>
-          </a:solidFill>
-          <a:ln>
-            <a:noFill/>
-          </a:ln>
-        </p:spPr>
-        <p:txBody>
-          <a:bodyPr/>
-          <a:lstStyle/>
-          <a:p>
-            <a:endParaRPr/>
-          </a:p>
-        </p:txBody>
-      </p:sp>
-      <p:sp>
-        <p:nvSpPr>
-          <p:cNvPr id="5006" name="SimReal 5006"/>
-          <p:cNvSpPr txBox="1"/>
-          <p:nvPr/>
-        </p:nvSpPr>
-        <p:spPr>
-          <a:xfrm>
-            <a:off x="548640" y="1554480"/>
-            <a:ext cx="2103120" cy="256032"/>
-          </a:xfrm>
-          <a:prstGeom prst="rect">
-            <a:avLst/>
-          </a:prstGeom>
-          <a:noFill/>
-          <a:ln>
-            <a:noFill/>
-          </a:ln>
-        </p:spPr>
-        <p:txBody>
-          <a:bodyPr spcFirstLastPara="1" wrap="square" lIns="0" tIns="0" rIns="0" bIns="0" anchor="ctr" anchorCtr="0">
-            <a:noAutofit/>
-          </a:bodyPr>
-          <a:lstStyle/>
-          <a:p>
-            <a:pPr marL="0" marR="0" lvl="0" indent="0" algn="l" rtl="0">
-              <a:spcBef>
-                <a:spcPts val="0"/>
-              </a:spcBef>
-              <a:spcAft>
-                <a:spcPts val="0"/>
-              </a:spcAft>
-              <a:buNone/>
-            </a:pPr>
-            <a:r>
-              <a:rPr lang="zh-CN" sz="950" b="0" i="0" u="none" strike="noStrike" cap="none">
+          <p:cNvSpPr txBox="1"/>
+          <p:nvPr/>
+        </p:nvSpPr>
+        <p:spPr>
+          <a:xfrm>
+            <a:off x="548640" y="1499616"/>
+            <a:ext cx="8229600" cy="201168"/>
+          </a:xfrm>
+          <a:prstGeom prst="rect">
+            <a:avLst/>
+          </a:prstGeom>
+          <a:noFill/>
+          <a:ln>
+            <a:noFill/>
+          </a:ln>
+        </p:spPr>
+        <p:txBody>
+          <a:bodyPr spcFirstLastPara="1" wrap="square" lIns="0" tIns="0" rIns="0" bIns="0" anchor="t" anchorCtr="0">
+            <a:noAutofit/>
+          </a:bodyPr>
+          <a:lstStyle/>
+          <a:p>
+            <a:pPr marL="0" marR="0" lvl="0" indent="0" algn="l" rtl="0">
+              <a:spcBef>
+                <a:spcPts val="0"/>
+              </a:spcBef>
+              <a:spcAft>
+                <a:spcPts val="0"/>
+              </a:spcAft>
+              <a:buNone/>
+            </a:pPr>
+            <a:r>
+              <a:rPr lang="zh-CN" sz="1000" b="0" i="0" u="none" strike="noStrike" cap="none">
                 <a:solidFill>
                   <a:srgbClr val="6E6C66"/>
                 </a:solidFill>
@@ -35943,8 +36009,37 @@
                 <a:cs typeface="IBM Plex Mono"/>
                 <a:sym typeface="IBM Plex Mono"/>
               </a:rPr>
-              <a:t>风险</a:t>
-            </a:r>
+              <a:t>2026年9月：个人Agent开始替人花钱，也开始替人出错</a:t>
+            </a:r>
+          </a:p>
+        </p:txBody>
+      </p:sp>
+      <p:sp>
+        <p:nvSpPr>
+          <p:cNvPr id="5006" name="SimReal 5006"/>
+          <p:cNvSpPr/>
+          <p:nvPr/>
+        </p:nvSpPr>
+        <p:spPr>
+          <a:xfrm>
+            <a:off x="548640" y="1755648"/>
+            <a:ext cx="2567178" cy="18288"/>
+          </a:xfrm>
+          <a:prstGeom prst="rect">
+            <a:avLst/>
+          </a:prstGeom>
+          <a:solidFill>
+            <a:srgbClr val="111110"/>
+          </a:solidFill>
+          <a:ln>
+            <a:noFill/>
+          </a:ln>
+        </p:spPr>
+        <p:txBody>
+          <a:bodyPr/>
+          <a:lstStyle/>
+          <a:p>
+            <a:endParaRPr/>
           </a:p>
         </p:txBody>
       </p:sp>
@@ -35956,34 +36051,629 @@
         </p:nvSpPr>
         <p:spPr>
           <a:xfrm>
-            <a:off x="2743200" y="1554480"/>
-            <a:ext cx="3200400" cy="256032"/>
-          </a:xfrm>
-          <a:prstGeom prst="rect">
-            <a:avLst/>
-          </a:prstGeom>
-          <a:noFill/>
-          <a:ln>
-            <a:noFill/>
-          </a:ln>
-        </p:spPr>
-        <p:txBody>
-          <a:bodyPr spcFirstLastPara="1" wrap="square" lIns="0" tIns="0" rIns="0" bIns="0" anchor="ctr" anchorCtr="0">
-            <a:noAutofit/>
-          </a:bodyPr>
-          <a:lstStyle/>
-          <a:p>
-            <a:pPr marL="0" marR="0" lvl="0" indent="0" algn="l" rtl="0">
-              <a:spcBef>
-                <a:spcPts val="0"/>
-              </a:spcBef>
-              <a:spcAft>
-                <a:spcPts val="0"/>
-              </a:spcAft>
-              <a:buNone/>
-            </a:pPr>
-            <a:r>
-              <a:rPr lang="zh-CN" sz="950" b="0" i="0" u="none" strike="noStrike" cap="none">
+            <a:off x="548640" y="1865376"/>
+            <a:ext cx="2567178" cy="603504"/>
+          </a:xfrm>
+          <a:prstGeom prst="rect">
+            <a:avLst/>
+          </a:prstGeom>
+          <a:noFill/>
+          <a:ln>
+            <a:noFill/>
+          </a:ln>
+        </p:spPr>
+        <p:txBody>
+          <a:bodyPr spcFirstLastPara="1" wrap="square" lIns="0" tIns="0" rIns="0" bIns="0" anchor="t" anchorCtr="0">
+            <a:noAutofit/>
+          </a:bodyPr>
+          <a:lstStyle/>
+          <a:p>
+            <a:pPr marL="0" marR="0" lvl="0" indent="0" algn="l" rtl="0">
+              <a:spcBef>
+                <a:spcPts val="0"/>
+              </a:spcBef>
+              <a:spcAft>
+                <a:spcPts val="0"/>
+              </a:spcAft>
+              <a:buNone/>
+            </a:pPr>
+            <a:r>
+              <a:rPr lang="zh-CN" sz="3600" b="0" i="0" u="none" strike="noStrike" cap="none">
+                <a:solidFill>
+                  <a:srgbClr val="111110"/>
+                </a:solidFill>
+                <a:latin typeface="Newsreader"/>
+                <a:ea typeface="Newsreader"/>
+                <a:cs typeface="Newsreader"/>
+                <a:sym typeface="Newsreader"/>
+              </a:rPr>
+              <a:t>Muse</a:t>
+            </a:r>
+          </a:p>
+        </p:txBody>
+      </p:sp>
+      <p:sp>
+        <p:nvSpPr>
+          <p:cNvPr id="5008" name="SimReal 5008"/>
+          <p:cNvSpPr txBox="1"/>
+          <p:nvPr/>
+        </p:nvSpPr>
+        <p:spPr>
+          <a:xfrm>
+            <a:off x="548640" y="2523744"/>
+            <a:ext cx="2567178" cy="457200"/>
+          </a:xfrm>
+          <a:prstGeom prst="rect">
+            <a:avLst/>
+          </a:prstGeom>
+          <a:noFill/>
+          <a:ln>
+            <a:noFill/>
+          </a:ln>
+        </p:spPr>
+        <p:txBody>
+          <a:bodyPr spcFirstLastPara="1" wrap="square" lIns="0" tIns="0" rIns="0" bIns="0" anchor="t" anchorCtr="0">
+            <a:noAutofit/>
+          </a:bodyPr>
+          <a:lstStyle/>
+          <a:p>
+            <a:pPr marL="0" marR="0" lvl="0" indent="0" algn="l" rtl="0">
+              <a:lnSpc>
+                <a:spcPct val="110000"/>
+              </a:lnSpc>
+              <a:spcBef>
+                <a:spcPts val="0"/>
+              </a:spcBef>
+              <a:spcAft>
+                <a:spcPts val="0"/>
+              </a:spcAft>
+              <a:buNone/>
+            </a:pPr>
+            <a:r>
+              <a:rPr lang="zh-CN" sz="1150" b="0" i="0" u="none" strike="noStrike" cap="none">
+                <a:solidFill>
+                  <a:srgbClr val="33322F"/>
+                </a:solidFill>
+                <a:latin typeface="Instrument Sans"/>
+                <a:ea typeface="Instrument Sans"/>
+                <a:cs typeface="Instrument Sans"/>
+                <a:sym typeface="Instrument Sans"/>
+              </a:rPr>
+              <a:t>Meta，9月8日上线</a:t>
+            </a:r>
+          </a:p>
+          <a:p>
+            <a:pPr marL="0" marR="0" lvl="0" indent="0" algn="l" rtl="0">
+              <a:lnSpc>
+                <a:spcPct val="110000"/>
+              </a:lnSpc>
+              <a:spcBef>
+                <a:spcPts val="0"/>
+              </a:spcBef>
+              <a:spcAft>
+                <a:spcPts val="0"/>
+              </a:spcAft>
+              <a:buNone/>
+            </a:pPr>
+            <a:r>
+              <a:rPr lang="zh-CN" sz="1150" b="0" i="0" u="none" strike="noStrike" cap="none">
+                <a:solidFill>
+                  <a:srgbClr val="33322F"/>
+                </a:solidFill>
+                <a:latin typeface="Instrument Sans"/>
+                <a:ea typeface="Instrument Sans"/>
+                <a:cs typeface="Instrument Sans"/>
+                <a:sym typeface="Instrument Sans"/>
+              </a:rPr>
+              <a:t>10天登顶美国App Store</a:t>
+            </a:r>
+          </a:p>
+        </p:txBody>
+      </p:sp>
+      <p:sp>
+        <p:nvSpPr>
+          <p:cNvPr id="5009" name="SimReal 5009"/>
+          <p:cNvSpPr/>
+          <p:nvPr/>
+        </p:nvSpPr>
+        <p:spPr>
+          <a:xfrm>
+            <a:off x="3390138" y="1755648"/>
+            <a:ext cx="2567178" cy="18288"/>
+          </a:xfrm>
+          <a:prstGeom prst="rect">
+            <a:avLst/>
+          </a:prstGeom>
+          <a:solidFill>
+            <a:srgbClr val="111110"/>
+          </a:solidFill>
+          <a:ln>
+            <a:noFill/>
+          </a:ln>
+        </p:spPr>
+        <p:txBody>
+          <a:bodyPr/>
+          <a:lstStyle/>
+          <a:p>
+            <a:endParaRPr/>
+          </a:p>
+        </p:txBody>
+      </p:sp>
+      <p:sp>
+        <p:nvSpPr>
+          <p:cNvPr id="5010" name="SimReal 5010"/>
+          <p:cNvSpPr txBox="1"/>
+          <p:nvPr/>
+        </p:nvSpPr>
+        <p:spPr>
+          <a:xfrm>
+            <a:off x="3390138" y="1865376"/>
+            <a:ext cx="2567178" cy="603504"/>
+          </a:xfrm>
+          <a:prstGeom prst="rect">
+            <a:avLst/>
+          </a:prstGeom>
+          <a:noFill/>
+          <a:ln>
+            <a:noFill/>
+          </a:ln>
+        </p:spPr>
+        <p:txBody>
+          <a:bodyPr spcFirstLastPara="1" wrap="square" lIns="0" tIns="0" rIns="0" bIns="0" anchor="t" anchorCtr="0">
+            <a:noAutofit/>
+          </a:bodyPr>
+          <a:lstStyle/>
+          <a:p>
+            <a:pPr marL="0" marR="0" lvl="0" indent="0" algn="l" rtl="0">
+              <a:spcBef>
+                <a:spcPts val="0"/>
+              </a:spcBef>
+              <a:spcAft>
+                <a:spcPts val="0"/>
+              </a:spcAft>
+              <a:buNone/>
+            </a:pPr>
+            <a:r>
+              <a:rPr lang="zh-CN" sz="3600" b="0" i="0" u="none" strike="noStrike" cap="none">
+                <a:solidFill>
+                  <a:srgbClr val="111110"/>
+                </a:solidFill>
+                <a:latin typeface="Newsreader"/>
+                <a:ea typeface="Newsreader"/>
+                <a:cs typeface="Newsreader"/>
+                <a:sym typeface="Newsreader"/>
+              </a:rPr>
+              <a:t>Dots</a:t>
+            </a:r>
+          </a:p>
+        </p:txBody>
+      </p:sp>
+      <p:sp>
+        <p:nvSpPr>
+          <p:cNvPr id="5011" name="SimReal 5011"/>
+          <p:cNvSpPr txBox="1"/>
+          <p:nvPr/>
+        </p:nvSpPr>
+        <p:spPr>
+          <a:xfrm>
+            <a:off x="3390138" y="2523744"/>
+            <a:ext cx="2567178" cy="457200"/>
+          </a:xfrm>
+          <a:prstGeom prst="rect">
+            <a:avLst/>
+          </a:prstGeom>
+          <a:noFill/>
+          <a:ln>
+            <a:noFill/>
+          </a:ln>
+        </p:spPr>
+        <p:txBody>
+          <a:bodyPr spcFirstLastPara="1" wrap="square" lIns="0" tIns="0" rIns="0" bIns="0" anchor="t" anchorCtr="0">
+            <a:noAutofit/>
+          </a:bodyPr>
+          <a:lstStyle/>
+          <a:p>
+            <a:pPr marL="0" marR="0" lvl="0" indent="0" algn="l" rtl="0">
+              <a:lnSpc>
+                <a:spcPct val="110000"/>
+              </a:lnSpc>
+              <a:spcBef>
+                <a:spcPts val="0"/>
+              </a:spcBef>
+              <a:spcAft>
+                <a:spcPts val="0"/>
+              </a:spcAft>
+              <a:buNone/>
+            </a:pPr>
+            <a:r>
+              <a:rPr lang="zh-CN" sz="1150" b="0" i="0" u="none" strike="noStrike" cap="none">
+                <a:solidFill>
+                  <a:srgbClr val="33322F"/>
+                </a:solidFill>
+                <a:latin typeface="Instrument Sans"/>
+                <a:ea typeface="Instrument Sans"/>
+                <a:cs typeface="Instrument Sans"/>
+                <a:sym typeface="Instrument Sans"/>
+              </a:rPr>
+              <a:t>OpenAI，9月29日发布</a:t>
+            </a:r>
+          </a:p>
+          <a:p>
+            <a:pPr marL="0" marR="0" lvl="0" indent="0" algn="l" rtl="0">
+              <a:lnSpc>
+                <a:spcPct val="110000"/>
+              </a:lnSpc>
+              <a:spcBef>
+                <a:spcPts val="0"/>
+              </a:spcBef>
+              <a:spcAft>
+                <a:spcPts val="0"/>
+              </a:spcAft>
+              <a:buNone/>
+            </a:pPr>
+            <a:r>
+              <a:rPr lang="zh-CN" sz="1150" b="0" i="0" u="none" strike="noStrike" cap="none">
+                <a:solidFill>
+                  <a:srgbClr val="33322F"/>
+                </a:solidFill>
+                <a:latin typeface="Instrument Sans"/>
+                <a:ea typeface="Instrument Sans"/>
+                <a:cs typeface="Instrument Sans"/>
+                <a:sym typeface="Instrument Sans"/>
+              </a:rPr>
+              <a:t>常驻云端，替人持续做事</a:t>
+            </a:r>
+          </a:p>
+        </p:txBody>
+      </p:sp>
+      <p:sp>
+        <p:nvSpPr>
+          <p:cNvPr id="5012" name="SimReal 5012"/>
+          <p:cNvSpPr/>
+          <p:nvPr/>
+        </p:nvSpPr>
+        <p:spPr>
+          <a:xfrm>
+            <a:off x="6231636" y="1755648"/>
+            <a:ext cx="2567178" cy="18288"/>
+          </a:xfrm>
+          <a:prstGeom prst="rect">
+            <a:avLst/>
+          </a:prstGeom>
+          <a:solidFill>
+            <a:srgbClr val="111110"/>
+          </a:solidFill>
+          <a:ln>
+            <a:noFill/>
+          </a:ln>
+        </p:spPr>
+        <p:txBody>
+          <a:bodyPr/>
+          <a:lstStyle/>
+          <a:p>
+            <a:endParaRPr/>
+          </a:p>
+        </p:txBody>
+      </p:sp>
+      <p:sp>
+        <p:nvSpPr>
+          <p:cNvPr id="5013" name="SimReal 5013"/>
+          <p:cNvSpPr txBox="1"/>
+          <p:nvPr/>
+        </p:nvSpPr>
+        <p:spPr>
+          <a:xfrm>
+            <a:off x="6231636" y="1865376"/>
+            <a:ext cx="2567178" cy="603504"/>
+          </a:xfrm>
+          <a:prstGeom prst="rect">
+            <a:avLst/>
+          </a:prstGeom>
+          <a:noFill/>
+          <a:ln>
+            <a:noFill/>
+          </a:ln>
+        </p:spPr>
+        <p:txBody>
+          <a:bodyPr spcFirstLastPara="1" wrap="square" lIns="0" tIns="0" rIns="0" bIns="0" anchor="t" anchorCtr="0">
+            <a:noAutofit/>
+          </a:bodyPr>
+          <a:lstStyle/>
+          <a:p>
+            <a:pPr marL="0" marR="0" lvl="0" indent="0" algn="l" rtl="0">
+              <a:spcBef>
+                <a:spcPts val="0"/>
+              </a:spcBef>
+              <a:spcAft>
+                <a:spcPts val="0"/>
+              </a:spcAft>
+              <a:buNone/>
+            </a:pPr>
+            <a:r>
+              <a:rPr lang="zh-CN" sz="3600" b="0" i="0" u="none" strike="noStrike" cap="none">
+                <a:solidFill>
+                  <a:srgbClr val="111110"/>
+                </a:solidFill>
+                <a:latin typeface="Newsreader"/>
+                <a:ea typeface="Newsreader"/>
+                <a:cs typeface="Newsreader"/>
+                <a:sym typeface="Newsreader"/>
+              </a:rPr>
+              <a:t>100亿美元</a:t>
+            </a:r>
+          </a:p>
+        </p:txBody>
+      </p:sp>
+      <p:sp>
+        <p:nvSpPr>
+          <p:cNvPr id="5014" name="SimReal 5014"/>
+          <p:cNvSpPr txBox="1"/>
+          <p:nvPr/>
+        </p:nvSpPr>
+        <p:spPr>
+          <a:xfrm>
+            <a:off x="6231636" y="2523744"/>
+            <a:ext cx="2567178" cy="457200"/>
+          </a:xfrm>
+          <a:prstGeom prst="rect">
+            <a:avLst/>
+          </a:prstGeom>
+          <a:noFill/>
+          <a:ln>
+            <a:noFill/>
+          </a:ln>
+        </p:spPr>
+        <p:txBody>
+          <a:bodyPr spcFirstLastPara="1" wrap="square" lIns="0" tIns="0" rIns="0" bIns="0" anchor="t" anchorCtr="0">
+            <a:noAutofit/>
+          </a:bodyPr>
+          <a:lstStyle/>
+          <a:p>
+            <a:pPr marL="0" marR="0" lvl="0" indent="0" algn="l" rtl="0">
+              <a:lnSpc>
+                <a:spcPct val="110000"/>
+              </a:lnSpc>
+              <a:spcBef>
+                <a:spcPts val="0"/>
+              </a:spcBef>
+              <a:spcAft>
+                <a:spcPts val="0"/>
+              </a:spcAft>
+              <a:buNone/>
+            </a:pPr>
+            <a:r>
+              <a:rPr lang="zh-CN" sz="1150" b="0" i="0" u="none" strike="noStrike" cap="none">
+                <a:solidFill>
+                  <a:srgbClr val="33322F"/>
+                </a:solidFill>
+                <a:latin typeface="Instrument Sans"/>
+                <a:ea typeface="Instrument Sans"/>
+                <a:cs typeface="Instrument Sans"/>
+                <a:sym typeface="Instrument Sans"/>
+              </a:rPr>
+              <a:t>Instinct估值，33天涨4倍</a:t>
+            </a:r>
+          </a:p>
+          <a:p>
+            <a:pPr marL="0" marR="0" lvl="0" indent="0" algn="l" rtl="0">
+              <a:lnSpc>
+                <a:spcPct val="110000"/>
+              </a:lnSpc>
+              <a:spcBef>
+                <a:spcPts val="0"/>
+              </a:spcBef>
+              <a:spcAft>
+                <a:spcPts val="0"/>
+              </a:spcAft>
+              <a:buNone/>
+            </a:pPr>
+            <a:r>
+              <a:rPr lang="zh-CN" sz="1150" b="0" i="0" u="none" strike="noStrike" cap="none">
+                <a:solidFill>
+                  <a:srgbClr val="33322F"/>
+                </a:solidFill>
+                <a:latin typeface="Instrument Sans"/>
+                <a:ea typeface="Instrument Sans"/>
+                <a:cs typeface="Instrument Sans"/>
+                <a:sym typeface="Instrument Sans"/>
+              </a:rPr>
+              <a:t>红杉、Benchmark、Coatue投资</a:t>
+            </a:r>
+          </a:p>
+        </p:txBody>
+      </p:sp>
+      <p:sp>
+        <p:nvSpPr>
+          <p:cNvPr id="5015" name="SimReal 5015"/>
+          <p:cNvSpPr/>
+          <p:nvPr/>
+        </p:nvSpPr>
+        <p:spPr>
+          <a:xfrm>
+            <a:off x="9073134" y="1755648"/>
+            <a:ext cx="2567178" cy="18288"/>
+          </a:xfrm>
+          <a:prstGeom prst="rect">
+            <a:avLst/>
+          </a:prstGeom>
+          <a:solidFill>
+            <a:srgbClr val="C2410C"/>
+          </a:solidFill>
+          <a:ln>
+            <a:noFill/>
+          </a:ln>
+        </p:spPr>
+        <p:txBody>
+          <a:bodyPr/>
+          <a:lstStyle/>
+          <a:p>
+            <a:endParaRPr/>
+          </a:p>
+        </p:txBody>
+      </p:sp>
+      <p:sp>
+        <p:nvSpPr>
+          <p:cNvPr id="5016" name="SimReal 5016"/>
+          <p:cNvSpPr txBox="1"/>
+          <p:nvPr/>
+        </p:nvSpPr>
+        <p:spPr>
+          <a:xfrm>
+            <a:off x="9073134" y="1865376"/>
+            <a:ext cx="2567178" cy="603504"/>
+          </a:xfrm>
+          <a:prstGeom prst="rect">
+            <a:avLst/>
+          </a:prstGeom>
+          <a:noFill/>
+          <a:ln>
+            <a:noFill/>
+          </a:ln>
+        </p:spPr>
+        <p:txBody>
+          <a:bodyPr spcFirstLastPara="1" wrap="square" lIns="0" tIns="0" rIns="0" bIns="0" anchor="t" anchorCtr="0">
+            <a:noAutofit/>
+          </a:bodyPr>
+          <a:lstStyle/>
+          <a:p>
+            <a:pPr marL="0" marR="0" lvl="0" indent="0" algn="l" rtl="0">
+              <a:spcBef>
+                <a:spcPts val="0"/>
+              </a:spcBef>
+              <a:spcAft>
+                <a:spcPts val="0"/>
+              </a:spcAft>
+              <a:buNone/>
+            </a:pPr>
+            <a:r>
+              <a:rPr lang="zh-CN" sz="3600" b="0" i="0" u="none" strike="noStrike" cap="none">
+                <a:solidFill>
+                  <a:srgbClr val="C2410C"/>
+                </a:solidFill>
+                <a:latin typeface="Newsreader"/>
+                <a:ea typeface="Newsreader"/>
+                <a:cs typeface="Newsreader"/>
+                <a:sym typeface="Newsreader"/>
+              </a:rPr>
+              <a:t>200美元</a:t>
+            </a:r>
+          </a:p>
+        </p:txBody>
+      </p:sp>
+      <p:sp>
+        <p:nvSpPr>
+          <p:cNvPr id="5017" name="SimReal 5017"/>
+          <p:cNvSpPr txBox="1"/>
+          <p:nvPr/>
+        </p:nvSpPr>
+        <p:spPr>
+          <a:xfrm>
+            <a:off x="9073134" y="2523744"/>
+            <a:ext cx="2567178" cy="457200"/>
+          </a:xfrm>
+          <a:prstGeom prst="rect">
+            <a:avLst/>
+          </a:prstGeom>
+          <a:noFill/>
+          <a:ln>
+            <a:noFill/>
+          </a:ln>
+        </p:spPr>
+        <p:txBody>
+          <a:bodyPr spcFirstLastPara="1" wrap="square" lIns="0" tIns="0" rIns="0" bIns="0" anchor="t" anchorCtr="0">
+            <a:noAutofit/>
+          </a:bodyPr>
+          <a:lstStyle/>
+          <a:p>
+            <a:pPr marL="0" marR="0" lvl="0" indent="0" algn="l" rtl="0">
+              <a:lnSpc>
+                <a:spcPct val="110000"/>
+              </a:lnSpc>
+              <a:spcBef>
+                <a:spcPts val="0"/>
+              </a:spcBef>
+              <a:spcAft>
+                <a:spcPts val="0"/>
+              </a:spcAft>
+              <a:buNone/>
+            </a:pPr>
+            <a:r>
+              <a:rPr lang="zh-CN" sz="1150" b="0" i="0" u="none" strike="noStrike" cap="none">
+                <a:solidFill>
+                  <a:srgbClr val="33322F"/>
+                </a:solidFill>
+                <a:latin typeface="Instrument Sans"/>
+                <a:ea typeface="Instrument Sans"/>
+                <a:cs typeface="Instrument Sans"/>
+                <a:sym typeface="Instrument Sans"/>
+              </a:rPr>
+              <a:t>Instinct擅自替用户订位，</a:t>
+            </a:r>
+          </a:p>
+          <a:p>
+            <a:pPr marL="0" marR="0" lvl="0" indent="0" algn="l" rtl="0">
+              <a:lnSpc>
+                <a:spcPct val="110000"/>
+              </a:lnSpc>
+              <a:spcBef>
+                <a:spcPts val="0"/>
+              </a:spcBef>
+              <a:spcAft>
+                <a:spcPts val="0"/>
+              </a:spcAft>
+              <a:buNone/>
+            </a:pPr>
+            <a:r>
+              <a:rPr lang="zh-CN" sz="1150" b="0" i="0" u="none" strike="noStrike" cap="none">
+                <a:solidFill>
+                  <a:srgbClr val="33322F"/>
+                </a:solidFill>
+                <a:latin typeface="Instrument Sans"/>
+                <a:ea typeface="Instrument Sans"/>
+                <a:cs typeface="Instrument Sans"/>
+                <a:sym typeface="Instrument Sans"/>
+              </a:rPr>
+              <a:t>用户被收的取消费</a:t>
+            </a:r>
+          </a:p>
+        </p:txBody>
+      </p:sp>
+      <p:sp>
+        <p:nvSpPr>
+          <p:cNvPr id="5018" name="SimReal 5018"/>
+          <p:cNvSpPr txBox="1"/>
+          <p:nvPr/>
+        </p:nvSpPr>
+        <p:spPr>
+          <a:xfrm>
+            <a:off x="548640" y="3200400"/>
+            <a:ext cx="8229600" cy="201168"/>
+          </a:xfrm>
+          <a:prstGeom prst="rect">
+            <a:avLst/>
+          </a:prstGeom>
+          <a:noFill/>
+          <a:ln>
+            <a:noFill/>
+          </a:ln>
+        </p:spPr>
+        <p:txBody>
+          <a:bodyPr spcFirstLastPara="1" wrap="square" lIns="0" tIns="0" rIns="0" bIns="0" anchor="t" anchorCtr="0">
+            <a:noAutofit/>
+          </a:bodyPr>
+          <a:lstStyle/>
+          <a:p>
+            <a:pPr marL="0" marR="0" lvl="0" indent="0" algn="l" rtl="0">
+              <a:spcBef>
+                <a:spcPts val="0"/>
+              </a:spcBef>
+              <a:spcAft>
+                <a:spcPts val="0"/>
+              </a:spcAft>
+              <a:buNone/>
+            </a:pPr>
+            <a:r>
+              <a:rPr lang="zh-CN" sz="1000" b="0" i="0" u="none" strike="noStrike" cap="none">
                 <a:solidFill>
                   <a:srgbClr val="6E6C66"/>
                 </a:solidFill>
@@ -35992,21 +36682,50 @@
                 <a:cs typeface="IBM Plex Mono"/>
                 <a:sym typeface="IBM Plex Mono"/>
               </a:rPr>
-              <a:t>现状</a:t>
-            </a:r>
-          </a:p>
-        </p:txBody>
-      </p:sp>
-      <p:sp>
-        <p:nvSpPr>
-          <p:cNvPr id="5008" name="SimReal 5008"/>
-          <p:cNvSpPr txBox="1"/>
-          <p:nvPr/>
-        </p:nvSpPr>
-        <p:spPr>
-          <a:xfrm>
-            <a:off x="6080760" y="1554480"/>
-            <a:ext cx="3200400" cy="256032"/>
+              <a:t>我们怎么接：同一批环境，第二类客户</a:t>
+            </a:r>
+          </a:p>
+        </p:txBody>
+      </p:sp>
+      <p:sp>
+        <p:nvSpPr>
+          <p:cNvPr id="5019" name="SimReal 5019"/>
+          <p:cNvSpPr/>
+          <p:nvPr/>
+        </p:nvSpPr>
+        <p:spPr>
+          <a:xfrm>
+            <a:off x="548640" y="3456432"/>
+            <a:ext cx="11091672" cy="9144"/>
+          </a:xfrm>
+          <a:prstGeom prst="rect">
+            <a:avLst/>
+          </a:prstGeom>
+          <a:solidFill>
+            <a:srgbClr val="111110"/>
+          </a:solidFill>
+          <a:ln>
+            <a:noFill/>
+          </a:ln>
+        </p:spPr>
+        <p:txBody>
+          <a:bodyPr/>
+          <a:lstStyle/>
+          <a:p>
+            <a:endParaRPr/>
+          </a:p>
+        </p:txBody>
+      </p:sp>
+      <p:sp>
+        <p:nvSpPr>
+          <p:cNvPr id="5020" name="SimReal 5020"/>
+          <p:cNvSpPr txBox="1"/>
+          <p:nvPr/>
+        </p:nvSpPr>
+        <p:spPr>
+          <a:xfrm>
+            <a:off x="548640" y="3456432"/>
+            <a:ext cx="1463040" cy="384048"/>
           </a:xfrm>
           <a:prstGeom prst="rect">
             <a:avLst/>
@@ -36032,7 +36751,735 @@
               <a:buNone/>
             </a:pPr>
             <a:r>
-              <a:rPr lang="zh-CN" sz="950" b="0" i="0" u="none" strike="noStrike" cap="none">
+              <a:rPr lang="zh-CN" sz="1200" b="1" i="0" u="none" strike="noStrike" cap="none">
+                <a:solidFill>
+                  <a:srgbClr val="C2410C"/>
+                </a:solidFill>
+                <a:latin typeface="Instrument Sans"/>
+                <a:ea typeface="Instrument Sans"/>
+                <a:cs typeface="Instrument Sans"/>
+                <a:sym typeface="Instrument Sans"/>
+              </a:rPr>
+              <a:t>开放什么</a:t>
+            </a:r>
+          </a:p>
+        </p:txBody>
+      </p:sp>
+      <p:sp>
+        <p:nvSpPr>
+          <p:cNvPr id="5021" name="SimReal 5021"/>
+          <p:cNvSpPr txBox="1"/>
+          <p:nvPr/>
+        </p:nvSpPr>
+        <p:spPr>
+          <a:xfrm>
+            <a:off x="2103120" y="3456432"/>
+            <a:ext cx="9537192" cy="384048"/>
+          </a:xfrm>
+          <a:prstGeom prst="rect">
+            <a:avLst/>
+          </a:prstGeom>
+          <a:noFill/>
+          <a:ln>
+            <a:noFill/>
+          </a:ln>
+        </p:spPr>
+        <p:txBody>
+          <a:bodyPr spcFirstLastPara="1" wrap="square" lIns="0" tIns="0" rIns="0" bIns="0" anchor="ctr" anchorCtr="0">
+            <a:noAutofit/>
+          </a:bodyPr>
+          <a:lstStyle/>
+          <a:p>
+            <a:pPr marL="0" marR="0" lvl="0" indent="0" algn="l" rtl="0">
+              <a:spcBef>
+                <a:spcPts val="0"/>
+              </a:spcBef>
+              <a:spcAft>
+                <a:spcPts val="0"/>
+              </a:spcAft>
+              <a:buNone/>
+            </a:pPr>
+            <a:r>
+              <a:rPr lang="zh-CN" sz="1200" b="0" i="0" u="none" strike="noStrike" cap="none">
+                <a:solidFill>
+                  <a:srgbClr val="111110"/>
+                </a:solidFill>
+                <a:latin typeface="Instrument Sans"/>
+                <a:ea typeface="Instrument Sans"/>
+                <a:cs typeface="Instrument Sans"/>
+                <a:sym typeface="Instrument Sans"/>
+              </a:rPr>
+              <a:t>交易与事件预测两个环境；留出集不开放练习</a:t>
+            </a:r>
+          </a:p>
+        </p:txBody>
+      </p:sp>
+      <p:sp>
+        <p:nvSpPr>
+          <p:cNvPr id="5022" name="SimReal 5022"/>
+          <p:cNvSpPr/>
+          <p:nvPr/>
+        </p:nvSpPr>
+        <p:spPr>
+          <a:xfrm>
+            <a:off x="548640" y="3840480"/>
+            <a:ext cx="11091672" cy="9144"/>
+          </a:xfrm>
+          <a:prstGeom prst="rect">
+            <a:avLst/>
+          </a:prstGeom>
+          <a:solidFill>
+            <a:srgbClr val="E2E0DA"/>
+          </a:solidFill>
+          <a:ln>
+            <a:noFill/>
+          </a:ln>
+        </p:spPr>
+        <p:txBody>
+          <a:bodyPr/>
+          <a:lstStyle/>
+          <a:p>
+            <a:endParaRPr/>
+          </a:p>
+        </p:txBody>
+      </p:sp>
+      <p:sp>
+        <p:nvSpPr>
+          <p:cNvPr id="5023" name="SimReal 5023"/>
+          <p:cNvSpPr txBox="1"/>
+          <p:nvPr/>
+        </p:nvSpPr>
+        <p:spPr>
+          <a:xfrm>
+            <a:off x="548640" y="3840480"/>
+            <a:ext cx="1463040" cy="384048"/>
+          </a:xfrm>
+          <a:prstGeom prst="rect">
+            <a:avLst/>
+          </a:prstGeom>
+          <a:noFill/>
+          <a:ln>
+            <a:noFill/>
+          </a:ln>
+        </p:spPr>
+        <p:txBody>
+          <a:bodyPr spcFirstLastPara="1" wrap="square" lIns="0" tIns="0" rIns="0" bIns="0" anchor="ctr" anchorCtr="0">
+            <a:noAutofit/>
+          </a:bodyPr>
+          <a:lstStyle/>
+          <a:p>
+            <a:pPr marL="0" marR="0" lvl="0" indent="0" algn="l" rtl="0">
+              <a:spcBef>
+                <a:spcPts val="0"/>
+              </a:spcBef>
+              <a:spcAft>
+                <a:spcPts val="0"/>
+              </a:spcAft>
+              <a:buNone/>
+            </a:pPr>
+            <a:r>
+              <a:rPr lang="zh-CN" sz="1200" b="1" i="0" u="none" strike="noStrike" cap="none">
+                <a:solidFill>
+                  <a:srgbClr val="C2410C"/>
+                </a:solidFill>
+                <a:latin typeface="Instrument Sans"/>
+                <a:ea typeface="Instrument Sans"/>
+                <a:cs typeface="Instrument Sans"/>
+                <a:sym typeface="Instrument Sans"/>
+              </a:rPr>
+              <a:t>怎么收费</a:t>
+            </a:r>
+          </a:p>
+        </p:txBody>
+      </p:sp>
+      <p:sp>
+        <p:nvSpPr>
+          <p:cNvPr id="5024" name="SimReal 5024"/>
+          <p:cNvSpPr txBox="1"/>
+          <p:nvPr/>
+        </p:nvSpPr>
+        <p:spPr>
+          <a:xfrm>
+            <a:off x="2103120" y="3840480"/>
+            <a:ext cx="9537192" cy="384048"/>
+          </a:xfrm>
+          <a:prstGeom prst="rect">
+            <a:avLst/>
+          </a:prstGeom>
+          <a:noFill/>
+          <a:ln>
+            <a:noFill/>
+          </a:ln>
+        </p:spPr>
+        <p:txBody>
+          <a:bodyPr spcFirstLastPara="1" wrap="square" lIns="0" tIns="0" rIns="0" bIns="0" anchor="ctr" anchorCtr="0">
+            <a:noAutofit/>
+          </a:bodyPr>
+          <a:lstStyle/>
+          <a:p>
+            <a:pPr marL="0" marR="0" lvl="0" indent="0" algn="l" rtl="0">
+              <a:spcBef>
+                <a:spcPts val="0"/>
+              </a:spcBef>
+              <a:spcAft>
+                <a:spcPts val="0"/>
+              </a:spcAft>
+              <a:buNone/>
+            </a:pPr>
+            <a:r>
+              <a:rPr lang="zh-CN" sz="1200" b="0" i="0" u="none" strike="noStrike" cap="none">
+                <a:solidFill>
+                  <a:srgbClr val="111110"/>
+                </a:solidFill>
+                <a:latin typeface="Instrument Sans"/>
+                <a:ea typeface="Instrument Sans"/>
+                <a:cs typeface="Instrument Sans"/>
+                <a:sym typeface="Instrument Sans"/>
+              </a:rPr>
+              <a:t>按练习回合计费，默认保密【待补：单价】</a:t>
+            </a:r>
+          </a:p>
+        </p:txBody>
+      </p:sp>
+      <p:sp>
+        <p:nvSpPr>
+          <p:cNvPr id="5025" name="SimReal 5025"/>
+          <p:cNvSpPr/>
+          <p:nvPr/>
+        </p:nvSpPr>
+        <p:spPr>
+          <a:xfrm>
+            <a:off x="548640" y="4224528"/>
+            <a:ext cx="11091672" cy="9144"/>
+          </a:xfrm>
+          <a:prstGeom prst="rect">
+            <a:avLst/>
+          </a:prstGeom>
+          <a:solidFill>
+            <a:srgbClr val="E2E0DA"/>
+          </a:solidFill>
+          <a:ln>
+            <a:noFill/>
+          </a:ln>
+        </p:spPr>
+        <p:txBody>
+          <a:bodyPr/>
+          <a:lstStyle/>
+          <a:p>
+            <a:endParaRPr/>
+          </a:p>
+        </p:txBody>
+      </p:sp>
+      <p:sp>
+        <p:nvSpPr>
+          <p:cNvPr id="5026" name="SimReal 5026"/>
+          <p:cNvSpPr txBox="1"/>
+          <p:nvPr/>
+        </p:nvSpPr>
+        <p:spPr>
+          <a:xfrm>
+            <a:off x="548640" y="4224528"/>
+            <a:ext cx="1463040" cy="384048"/>
+          </a:xfrm>
+          <a:prstGeom prst="rect">
+            <a:avLst/>
+          </a:prstGeom>
+          <a:noFill/>
+          <a:ln>
+            <a:noFill/>
+          </a:ln>
+        </p:spPr>
+        <p:txBody>
+          <a:bodyPr spcFirstLastPara="1" wrap="square" lIns="0" tIns="0" rIns="0" bIns="0" anchor="ctr" anchorCtr="0">
+            <a:noAutofit/>
+          </a:bodyPr>
+          <a:lstStyle/>
+          <a:p>
+            <a:pPr marL="0" marR="0" lvl="0" indent="0" algn="l" rtl="0">
+              <a:spcBef>
+                <a:spcPts val="0"/>
+              </a:spcBef>
+              <a:spcAft>
+                <a:spcPts val="0"/>
+              </a:spcAft>
+              <a:buNone/>
+            </a:pPr>
+            <a:r>
+              <a:rPr lang="zh-CN" sz="1200" b="1" i="0" u="none" strike="noStrike" cap="none">
+                <a:solidFill>
+                  <a:srgbClr val="C2410C"/>
+                </a:solidFill>
+                <a:latin typeface="Instrument Sans"/>
+                <a:ea typeface="Instrument Sans"/>
+                <a:cs typeface="Instrument Sans"/>
+                <a:sym typeface="Instrument Sans"/>
+              </a:rPr>
+              <a:t>数据规则</a:t>
+            </a:r>
+          </a:p>
+        </p:txBody>
+      </p:sp>
+      <p:sp>
+        <p:nvSpPr>
+          <p:cNvPr id="5027" name="SimReal 5027"/>
+          <p:cNvSpPr txBox="1"/>
+          <p:nvPr/>
+        </p:nvSpPr>
+        <p:spPr>
+          <a:xfrm>
+            <a:off x="2103120" y="4224528"/>
+            <a:ext cx="9537192" cy="384048"/>
+          </a:xfrm>
+          <a:prstGeom prst="rect">
+            <a:avLst/>
+          </a:prstGeom>
+          <a:noFill/>
+          <a:ln>
+            <a:noFill/>
+          </a:ln>
+        </p:spPr>
+        <p:txBody>
+          <a:bodyPr spcFirstLastPara="1" wrap="square" lIns="0" tIns="0" rIns="0" bIns="0" anchor="ctr" anchorCtr="0">
+            <a:noAutofit/>
+          </a:bodyPr>
+          <a:lstStyle/>
+          <a:p>
+            <a:pPr marL="0" marR="0" lvl="0" indent="0" algn="l" rtl="0">
+              <a:spcBef>
+                <a:spcPts val="0"/>
+              </a:spcBef>
+              <a:spcAft>
+                <a:spcPts val="0"/>
+              </a:spcAft>
+              <a:buNone/>
+            </a:pPr>
+            <a:r>
+              <a:rPr lang="zh-CN" sz="1200" b="0" i="0" u="none" strike="noStrike" cap="none">
+                <a:solidFill>
+                  <a:srgbClr val="111110"/>
+                </a:solidFill>
+                <a:latin typeface="Instrument Sans"/>
+                <a:ea typeface="Instrument Sans"/>
+                <a:cs typeface="Instrument Sans"/>
+                <a:sym typeface="Instrument Sans"/>
+              </a:rPr>
+              <a:t>脱敏共享轨迹，可换练习额度与收益分成；交给实验室的数据附授权记录</a:t>
+            </a:r>
+          </a:p>
+        </p:txBody>
+      </p:sp>
+      <p:sp>
+        <p:nvSpPr>
+          <p:cNvPr id="5028" name="SimReal 5028"/>
+          <p:cNvSpPr/>
+          <p:nvPr/>
+        </p:nvSpPr>
+        <p:spPr>
+          <a:xfrm>
+            <a:off x="548640" y="4608576"/>
+            <a:ext cx="11091672" cy="9144"/>
+          </a:xfrm>
+          <a:prstGeom prst="rect">
+            <a:avLst/>
+          </a:prstGeom>
+          <a:solidFill>
+            <a:srgbClr val="E2E0DA"/>
+          </a:solidFill>
+          <a:ln>
+            <a:noFill/>
+          </a:ln>
+        </p:spPr>
+        <p:txBody>
+          <a:bodyPr/>
+          <a:lstStyle/>
+          <a:p>
+            <a:endParaRPr/>
+          </a:p>
+        </p:txBody>
+      </p:sp>
+      <p:sp>
+        <p:nvSpPr>
+          <p:cNvPr id="5029" name="SimReal 5029"/>
+          <p:cNvSpPr txBox="1"/>
+          <p:nvPr/>
+        </p:nvSpPr>
+        <p:spPr>
+          <a:xfrm>
+            <a:off x="548640" y="4608576"/>
+            <a:ext cx="1463040" cy="384048"/>
+          </a:xfrm>
+          <a:prstGeom prst="rect">
+            <a:avLst/>
+          </a:prstGeom>
+          <a:noFill/>
+          <a:ln>
+            <a:noFill/>
+          </a:ln>
+        </p:spPr>
+        <p:txBody>
+          <a:bodyPr spcFirstLastPara="1" wrap="square" lIns="0" tIns="0" rIns="0" bIns="0" anchor="ctr" anchorCtr="0">
+            <a:noAutofit/>
+          </a:bodyPr>
+          <a:lstStyle/>
+          <a:p>
+            <a:pPr marL="0" marR="0" lvl="0" indent="0" algn="l" rtl="0">
+              <a:spcBef>
+                <a:spcPts val="0"/>
+              </a:spcBef>
+              <a:spcAft>
+                <a:spcPts val="0"/>
+              </a:spcAft>
+              <a:buNone/>
+            </a:pPr>
+            <a:r>
+              <a:rPr lang="zh-CN" sz="1200" b="1" i="0" u="none" strike="noStrike" cap="none">
+                <a:solidFill>
+                  <a:srgbClr val="C2410C"/>
+                </a:solidFill>
+                <a:latin typeface="Instrument Sans"/>
+                <a:ea typeface="Instrument Sans"/>
+                <a:cs typeface="Instrument Sans"/>
+                <a:sym typeface="Instrument Sans"/>
+              </a:rPr>
+              <a:t>验证节点</a:t>
+            </a:r>
+          </a:p>
+        </p:txBody>
+      </p:sp>
+      <p:sp>
+        <p:nvSpPr>
+          <p:cNvPr id="5030" name="SimReal 5030"/>
+          <p:cNvSpPr txBox="1"/>
+          <p:nvPr/>
+        </p:nvSpPr>
+        <p:spPr>
+          <a:xfrm>
+            <a:off x="2103120" y="4608576"/>
+            <a:ext cx="9537192" cy="384048"/>
+          </a:xfrm>
+          <a:prstGeom prst="rect">
+            <a:avLst/>
+          </a:prstGeom>
+          <a:noFill/>
+          <a:ln>
+            <a:noFill/>
+          </a:ln>
+        </p:spPr>
+        <p:txBody>
+          <a:bodyPr spcFirstLastPara="1" wrap="square" lIns="0" tIns="0" rIns="0" bIns="0" anchor="ctr" anchorCtr="0">
+            <a:noAutofit/>
+          </a:bodyPr>
+          <a:lstStyle/>
+          <a:p>
+            <a:pPr marL="0" marR="0" lvl="0" indent="0" algn="l" rtl="0">
+              <a:spcBef>
+                <a:spcPts val="0"/>
+              </a:spcBef>
+              <a:spcAft>
+                <a:spcPts val="0"/>
+              </a:spcAft>
+              <a:buNone/>
+            </a:pPr>
+            <a:r>
+              <a:rPr lang="zh-CN" sz="1200" b="0" i="0" u="none" strike="noStrike" cap="none">
+                <a:solidFill>
+                  <a:srgbClr val="111110"/>
+                </a:solidFill>
+                <a:latin typeface="Instrument Sans"/>
+                <a:ea typeface="Instrument Sans"/>
+                <a:cs typeface="Instrument Sans"/>
+                <a:sym typeface="Instrument Sans"/>
+              </a:rPr>
+              <a:t>【6个月】首批【X】个Agent团队接入</a:t>
+            </a:r>
+          </a:p>
+        </p:txBody>
+      </p:sp>
+      <p:sp>
+        <p:nvSpPr>
+          <p:cNvPr id="5031" name="SimReal 5031"/>
+          <p:cNvSpPr/>
+          <p:nvPr/>
+        </p:nvSpPr>
+        <p:spPr>
+          <a:xfrm>
+            <a:off x="548640" y="4992624"/>
+            <a:ext cx="11091672" cy="9144"/>
+          </a:xfrm>
+          <a:prstGeom prst="rect">
+            <a:avLst/>
+          </a:prstGeom>
+          <a:solidFill>
+            <a:srgbClr val="E2E0DA"/>
+          </a:solidFill>
+          <a:ln>
+            <a:noFill/>
+          </a:ln>
+        </p:spPr>
+        <p:txBody>
+          <a:bodyPr/>
+          <a:lstStyle/>
+          <a:p>
+            <a:endParaRPr/>
+          </a:p>
+        </p:txBody>
+      </p:sp>
+      <p:sp>
+        <p:nvSpPr>
+          <p:cNvPr id="5032" name="SimReal 5032"/>
+          <p:cNvSpPr txBox="1"/>
+          <p:nvPr/>
+        </p:nvSpPr>
+        <p:spPr>
+          <a:xfrm>
+            <a:off x="548640" y="5230368"/>
+            <a:ext cx="11091672" cy="420624"/>
+          </a:xfrm>
+          <a:prstGeom prst="rect">
+            <a:avLst/>
+          </a:prstGeom>
+          <a:noFill/>
+          <a:ln>
+            <a:noFill/>
+          </a:ln>
+        </p:spPr>
+        <p:txBody>
+          <a:bodyPr spcFirstLastPara="1" wrap="square" lIns="0" tIns="0" rIns="0" bIns="0" anchor="ctr" anchorCtr="0">
+            <a:noAutofit/>
+          </a:bodyPr>
+          <a:lstStyle/>
+          <a:p>
+            <a:pPr marL="0" marR="0" lvl="0" indent="0" algn="l" rtl="0">
+              <a:spcBef>
+                <a:spcPts val="0"/>
+              </a:spcBef>
+              <a:spcAft>
+                <a:spcPts val="0"/>
+              </a:spcAft>
+              <a:buNone/>
+            </a:pPr>
+            <a:r>
+              <a:rPr lang="zh-CN" sz="2200" b="0" i="0" u="none" strike="noStrike" cap="none">
+                <a:solidFill>
+                  <a:srgbClr val="111110"/>
+                </a:solidFill>
+                <a:latin typeface="Newsreader"/>
+                <a:ea typeface="Newsreader"/>
+                <a:cs typeface="Newsreader"/>
+                <a:sym typeface="Newsreader"/>
+              </a:rPr>
+              <a:t>沙盒让Agent不闯祸，</a:t>
+            </a:r>
+            <a:r>
+              <a:rPr lang="zh-CN" sz="2200" b="0" i="0" u="none" strike="noStrike" cap="none">
+                <a:solidFill>
+                  <a:srgbClr val="C2410C"/>
+                </a:solidFill>
+                <a:latin typeface="Newsreader"/>
+                <a:ea typeface="Newsreader"/>
+                <a:cs typeface="Newsreader"/>
+                <a:sym typeface="Newsreader"/>
+              </a:rPr>
+              <a:t>我们让它做对</a:t>
+            </a:r>
+            <a:r>
+              <a:rPr lang="zh-CN" sz="2200" b="0" i="0" u="none" strike="noStrike" cap="none">
+                <a:solidFill>
+                  <a:srgbClr val="111110"/>
+                </a:solidFill>
+                <a:latin typeface="Newsreader"/>
+                <a:ea typeface="Newsreader"/>
+                <a:cs typeface="Newsreader"/>
+                <a:sym typeface="Newsreader"/>
+              </a:rPr>
+              <a:t>。</a:t>
+            </a:r>
+          </a:p>
+        </p:txBody>
+      </p:sp>
+      <p:sp>
+        <p:nvSpPr>
+          <p:cNvPr id="5033" name="SimReal 5033"/>
+          <p:cNvSpPr txBox="1"/>
+          <p:nvPr/>
+        </p:nvSpPr>
+        <p:spPr>
+          <a:xfrm>
+            <a:off x="548640" y="5852160"/>
+            <a:ext cx="11091672" cy="219456"/>
+          </a:xfrm>
+          <a:prstGeom prst="rect">
+            <a:avLst/>
+          </a:prstGeom>
+          <a:noFill/>
+          <a:ln>
+            <a:noFill/>
+          </a:ln>
+        </p:spPr>
+        <p:txBody>
+          <a:bodyPr spcFirstLastPara="1" wrap="square" lIns="0" tIns="0" rIns="0" bIns="0" anchor="t" anchorCtr="0">
+            <a:noAutofit/>
+          </a:bodyPr>
+          <a:lstStyle/>
+          <a:p>
+            <a:pPr marL="0" marR="0" lvl="0" indent="0" algn="l" rtl="0">
+              <a:spcBef>
+                <a:spcPts val="0"/>
+              </a:spcBef>
+              <a:spcAft>
+                <a:spcPts val="0"/>
+              </a:spcAft>
+              <a:buNone/>
+            </a:pPr>
+            <a:r>
+              <a:rPr lang="zh-CN" sz="800" b="0" i="0" u="none" strike="noStrike" cap="none">
+                <a:solidFill>
+                  <a:srgbClr val="6E6C66"/>
+                </a:solidFill>
+                <a:latin typeface="Instrument Sans"/>
+                <a:ea typeface="Instrument Sans"/>
+                <a:cs typeface="Instrument Sans"/>
+                <a:sym typeface="Instrument Sans"/>
+              </a:rPr>
+              <a:t>来源：Meta与OpenAI发布（2026年9月）；TechCrunch（2026年9月25日）；Instinct（路透社，2026年9月28日；《大西洋月刊》、CNN，2026年9月）。详见A2。</a:t>
+            </a:r>
+          </a:p>
+        </p:txBody>
+      </p:sp>
+      <p:sp>
+        <p:nvSpPr>
+          <p:cNvPr id="5034" name="SimReal 5034"/>
+          <p:cNvSpPr txBox="1"/>
+          <p:nvPr/>
+        </p:nvSpPr>
+        <p:spPr>
+          <a:xfrm>
+            <a:off x="1243584" y="6382512"/>
+            <a:ext cx="457200" cy="237744"/>
+          </a:xfrm>
+          <a:prstGeom prst="rect">
+            <a:avLst/>
+          </a:prstGeom>
+          <a:noFill/>
+          <a:ln>
+            <a:noFill/>
+          </a:ln>
+        </p:spPr>
+        <p:txBody>
+          <a:bodyPr spcFirstLastPara="1" wrap="square" lIns="0" tIns="0" rIns="0" bIns="0" anchor="ctr" anchorCtr="0">
+            <a:noAutofit/>
+          </a:bodyPr>
+          <a:lstStyle/>
+          <a:p>
+            <a:pPr marL="0" marR="0" lvl="0" indent="0" algn="l" rtl="0">
+              <a:spcBef>
+                <a:spcPts val="0"/>
+              </a:spcBef>
+              <a:spcAft>
+                <a:spcPts val="0"/>
+              </a:spcAft>
+              <a:buNone/>
+            </a:pPr>
+            <a:r>
+              <a:rPr lang="zh-CN" sz="900" b="1" i="0" u="none" strike="noStrike" cap="none">
+                <a:solidFill>
+                  <a:srgbClr val="111110"/>
+                </a:solidFill>
+                <a:latin typeface="Instrument Sans"/>
+                <a:ea typeface="Instrument Sans"/>
+                <a:cs typeface="Instrument Sans"/>
+                <a:sym typeface="Instrument Sans"/>
+              </a:rPr>
+              <a:t>衍真</a:t>
+            </a:r>
+          </a:p>
+        </p:txBody>
+      </p:sp>
+      <p:sp>
+        <p:nvSpPr>
+          <p:cNvPr id="5035" name="SimReal 5035"/>
+          <p:cNvSpPr txBox="1"/>
+          <p:nvPr/>
+        </p:nvSpPr>
+        <p:spPr>
+          <a:xfrm>
+            <a:off x="1691640" y="6382512"/>
+            <a:ext cx="6858000" cy="237744"/>
+          </a:xfrm>
+          <a:prstGeom prst="rect">
+            <a:avLst/>
+          </a:prstGeom>
+          <a:noFill/>
+          <a:ln>
+            <a:noFill/>
+          </a:ln>
+        </p:spPr>
+        <p:txBody>
+          <a:bodyPr spcFirstLastPara="1" wrap="square" lIns="0" tIns="0" rIns="0" bIns="0" anchor="ctr" anchorCtr="0">
+            <a:noAutofit/>
+          </a:bodyPr>
+          <a:lstStyle/>
+          <a:p>
+            <a:pPr marL="0" marR="0" lvl="0" indent="0" algn="l" rtl="0">
+              <a:spcBef>
+                <a:spcPts val="0"/>
+              </a:spcBef>
+              <a:spcAft>
+                <a:spcPts val="0"/>
+              </a:spcAft>
+              <a:buNone/>
+            </a:pPr>
+            <a:r>
+              <a:rPr lang="zh-CN" sz="800" b="0" i="0" u="none" strike="noStrike" cap="none">
+                <a:solidFill>
+                  <a:srgbClr val="6E6C66"/>
+                </a:solidFill>
+                <a:latin typeface="Instrument Sans"/>
+                <a:ea typeface="Instrument Sans"/>
+                <a:cs typeface="Instrument Sans"/>
+                <a:sym typeface="Instrument Sans"/>
+              </a:rPr>
+              <a:t>机密  ·  仅供受邀投资机构内部评估使用  ·  2026年9月</a:t>
+            </a:r>
+          </a:p>
+        </p:txBody>
+      </p:sp>
+      <p:sp>
+        <p:nvSpPr>
+          <p:cNvPr id="5036" name="SimReal 5036"/>
+          <p:cNvSpPr txBox="1"/>
+          <p:nvPr/>
+        </p:nvSpPr>
+        <p:spPr>
+          <a:xfrm>
+            <a:off x="10725912" y="6382512"/>
+            <a:ext cx="914400" cy="237744"/>
+          </a:xfrm>
+          <a:prstGeom prst="rect">
+            <a:avLst/>
+          </a:prstGeom>
+          <a:noFill/>
+          <a:ln>
+            <a:noFill/>
+          </a:ln>
+        </p:spPr>
+        <p:txBody>
+          <a:bodyPr spcFirstLastPara="1" wrap="square" lIns="0" tIns="0" rIns="0" bIns="0" anchor="ctr" anchorCtr="0">
+            <a:noAutofit/>
+          </a:bodyPr>
+          <a:lstStyle/>
+          <a:p>
+            <a:pPr marL="0" marR="0" lvl="0" indent="0" algn="r" rtl="0">
+              <a:spcBef>
+                <a:spcPts val="0"/>
+              </a:spcBef>
+              <a:spcAft>
+                <a:spcPts val="0"/>
+              </a:spcAft>
+              <a:buNone/>
+            </a:pPr>
+            <a:r>
+              <a:rPr lang="zh-CN" sz="900" b="0" i="0" u="none" strike="noStrike" cap="none">
                 <a:solidFill>
                   <a:srgbClr val="6E6C66"/>
                 </a:solidFill>
@@ -36041,21 +37488,71 @@
                 <a:cs typeface="IBM Plex Mono"/>
                 <a:sym typeface="IBM Plex Mono"/>
               </a:rPr>
-              <a:t>对策</a:t>
-            </a:r>
-          </a:p>
-        </p:txBody>
-      </p:sp>
-      <p:sp>
-        <p:nvSpPr>
-          <p:cNvPr id="5009" name="SimReal 5009"/>
-          <p:cNvSpPr txBox="1"/>
-          <p:nvPr/>
-        </p:nvSpPr>
-        <p:spPr>
-          <a:xfrm>
-            <a:off x="9418320" y="1554480"/>
-            <a:ext cx="2221992" cy="256032"/>
+              <a:t>11</a:t>
+            </a:r>
+          </a:p>
+        </p:txBody>
+      </p:sp>
+    </p:spTree>
+  </p:cSld>
+  <p:clrMapOvr>
+    <a:masterClrMapping/>
+  </p:clrMapOvr>
+</p:sld>
+</file>
+
+<file path=ppt/slides/slide25.xml><?xml version="1.0" encoding="utf-8"?>
+<p:sld xmlns:a="http://schemas.openxmlformats.org/drawingml/2006/main" xmlns:p="http://schemas.openxmlformats.org/presentationml/2006/main" xmlns:r="http://schemas.openxmlformats.org/officeDocument/2006/relationships">
+  <p:cSld>
+    <p:bg>
+      <p:bgPr>
+        <a:solidFill>
+          <a:srgbClr val="FAF9F6"/>
+        </a:solidFill>
+        <a:effectLst/>
+      </p:bgPr>
+    </p:bg>
+    <p:spTree>
+      <p:nvGrpSpPr>
+        <p:cNvPr id="1" name=""/>
+        <p:cNvGrpSpPr/>
+        <p:nvPr/>
+      </p:nvGrpSpPr>
+      <p:grpSpPr/>
+      <p:pic>
+        <p:nvPicPr>
+          <p:cNvPr id="2" name="Picture 1" descr="image.png"/>
+          <p:cNvPicPr>
+            <a:picLocks noChangeAspect="1"/>
+          </p:cNvPicPr>
+          <p:nvPr/>
+        </p:nvPicPr>
+        <p:blipFill>
+          <a:blip r:embed="rId2"/>
+          <a:stretch>
+            <a:fillRect/>
+          </a:stretch>
+        </p:blipFill>
+        <p:spPr>
+          <a:xfrm>
+            <a:off x="548640" y="6419088"/>
+            <a:ext cx="640080" cy="172822"/>
+          </a:xfrm>
+          <a:prstGeom prst="rect">
+            <a:avLst/>
+          </a:prstGeom>
+        </p:spPr>
+      </p:pic>
+      <p:sp>
+        <p:nvSpPr>
+          <p:cNvPr id="5001" name="SimReal 5001"/>
+          <p:cNvSpPr txBox="1"/>
+          <p:nvPr/>
+        </p:nvSpPr>
+        <p:spPr>
+          <a:xfrm>
+            <a:off x="548640" y="384048"/>
+            <a:ext cx="2743200" cy="219456"/>
           </a:xfrm>
           <a:prstGeom prst="rect">
             <a:avLst/>
@@ -36081,59 +37578,30 @@
               <a:buNone/>
             </a:pPr>
             <a:r>
-              <a:rPr lang="zh-CN" sz="950" b="0" i="0" u="none" strike="noStrike" cap="none">
-                <a:solidFill>
-                  <a:srgbClr val="6E6C66"/>
+              <a:rPr lang="zh-CN" sz="1000" b="1" i="0" u="none" strike="noStrike" cap="none">
+                <a:solidFill>
+                  <a:srgbClr val="C2410C"/>
                 </a:solidFill>
                 <a:latin typeface="IBM Plex Mono"/>
                 <a:ea typeface="IBM Plex Mono"/>
                 <a:cs typeface="IBM Plex Mono"/>
                 <a:sym typeface="IBM Plex Mono"/>
               </a:rPr>
-              <a:t>验证节点</a:t>
-            </a:r>
-          </a:p>
-        </p:txBody>
-      </p:sp>
-      <p:sp>
-        <p:nvSpPr>
-          <p:cNvPr id="5010" name="SimReal 5010"/>
-          <p:cNvSpPr/>
-          <p:nvPr/>
-        </p:nvSpPr>
-        <p:spPr>
-          <a:xfrm>
-            <a:off x="548640" y="1847088"/>
-            <a:ext cx="11091672" cy="9144"/>
-          </a:xfrm>
-          <a:prstGeom prst="rect">
-            <a:avLst/>
-          </a:prstGeom>
-          <a:solidFill>
-            <a:srgbClr val="E2E0DA"/>
-          </a:solidFill>
-          <a:ln>
-            <a:noFill/>
-          </a:ln>
-        </p:spPr>
-        <p:txBody>
-          <a:bodyPr/>
-          <a:lstStyle/>
-          <a:p>
-            <a:endParaRPr/>
-          </a:p>
-        </p:txBody>
-      </p:sp>
-      <p:sp>
-        <p:nvSpPr>
-          <p:cNvPr id="5011" name="SimReal 5011"/>
-          <p:cNvSpPr txBox="1"/>
-          <p:nvPr/>
-        </p:nvSpPr>
-        <p:spPr>
-          <a:xfrm>
-            <a:off x="548640" y="1847088"/>
-            <a:ext cx="2103120" cy="640080"/>
+              <a:t>21</a:t>
+            </a:r>
+          </a:p>
+        </p:txBody>
+      </p:sp>
+      <p:sp>
+        <p:nvSpPr>
+          <p:cNvPr id="5002" name="SimReal 5002"/>
+          <p:cNvSpPr txBox="1"/>
+          <p:nvPr/>
+        </p:nvSpPr>
+        <p:spPr>
+          <a:xfrm>
+            <a:off x="6035040" y="384048"/>
+            <a:ext cx="5605272" cy="219456"/>
           </a:xfrm>
           <a:prstGeom prst="rect">
             <a:avLst/>
@@ -36149,17 +37617,186 @@
           </a:bodyPr>
           <a:lstStyle/>
           <a:p>
-            <a:pPr marL="0" marR="0" lvl="0" indent="0" algn="l" rtl="0">
-              <a:spcBef>
-                <a:spcPts val="0"/>
-              </a:spcBef>
-              <a:spcAft>
-                <a:spcPts val="0"/>
-              </a:spcAft>
-              <a:buNone/>
-            </a:pPr>
-            <a:r>
-              <a:rPr lang="zh-CN" sz="1500" b="0" i="0" u="none" strike="noStrike" cap="none">
+            <a:pPr marL="0" marR="0" lvl="0" indent="0" algn="r" rtl="0">
+              <a:spcBef>
+                <a:spcPts val="0"/>
+              </a:spcBef>
+              <a:spcAft>
+                <a:spcPts val="0"/>
+              </a:spcAft>
+              <a:buNone/>
+            </a:pPr>
+            <a:r>
+              <a:rPr lang="zh-CN" sz="850" b="0" i="0" u="none" strike="noStrike" cap="none">
+                <a:solidFill>
+                  <a:srgbClr val="9A978F"/>
+                </a:solidFill>
+                <a:latin typeface="Instrument Sans"/>
+                <a:ea typeface="Instrument Sans"/>
+                <a:cs typeface="Instrument Sans"/>
+                <a:sym typeface="Instrument Sans"/>
+              </a:rPr>
+              <a:t>我们是谁</a:t>
+            </a:r>
+            <a:r>
+              <a:rPr lang="zh-CN" sz="850" b="0" i="0" u="none" strike="noStrike" cap="none">
+                <a:solidFill>
+                  <a:srgbClr val="9A978F"/>
+                </a:solidFill>
+                <a:latin typeface="Instrument Sans"/>
+                <a:ea typeface="Instrument Sans"/>
+                <a:cs typeface="Instrument Sans"/>
+                <a:sym typeface="Instrument Sans"/>
+              </a:rPr>
+              <a:t>   </a:t>
+            </a:r>
+            <a:r>
+              <a:rPr lang="zh-CN" sz="850" b="0" i="0" u="none" strike="noStrike" cap="none">
+                <a:solidFill>
+                  <a:srgbClr val="9A978F"/>
+                </a:solidFill>
+                <a:latin typeface="Instrument Sans"/>
+                <a:ea typeface="Instrument Sans"/>
+                <a:cs typeface="Instrument Sans"/>
+                <a:sym typeface="Instrument Sans"/>
+              </a:rPr>
+              <a:t>问题与机会</a:t>
+            </a:r>
+            <a:r>
+              <a:rPr lang="zh-CN" sz="850" b="0" i="0" u="none" strike="noStrike" cap="none">
+                <a:solidFill>
+                  <a:srgbClr val="9A978F"/>
+                </a:solidFill>
+                <a:latin typeface="Instrument Sans"/>
+                <a:ea typeface="Instrument Sans"/>
+                <a:cs typeface="Instrument Sans"/>
+                <a:sym typeface="Instrument Sans"/>
+              </a:rPr>
+              <a:t>   </a:t>
+            </a:r>
+            <a:r>
+              <a:rPr lang="zh-CN" sz="850" b="0" i="0" u="none" strike="noStrike" cap="none">
+                <a:solidFill>
+                  <a:srgbClr val="9A978F"/>
+                </a:solidFill>
+                <a:latin typeface="Instrument Sans"/>
+                <a:ea typeface="Instrument Sans"/>
+                <a:cs typeface="Instrument Sans"/>
+                <a:sym typeface="Instrument Sans"/>
+              </a:rPr>
+              <a:t>我们的答案</a:t>
+            </a:r>
+            <a:r>
+              <a:rPr lang="zh-CN" sz="850" b="0" i="0" u="none" strike="noStrike" cap="none">
+                <a:solidFill>
+                  <a:srgbClr val="9A978F"/>
+                </a:solidFill>
+                <a:latin typeface="Instrument Sans"/>
+                <a:ea typeface="Instrument Sans"/>
+                <a:cs typeface="Instrument Sans"/>
+                <a:sym typeface="Instrument Sans"/>
+              </a:rPr>
+              <a:t>   </a:t>
+            </a:r>
+            <a:r>
+              <a:rPr lang="zh-CN" sz="850" b="0" i="0" u="none" strike="noStrike" cap="none">
+                <a:solidFill>
+                  <a:srgbClr val="9A978F"/>
+                </a:solidFill>
+                <a:latin typeface="Instrument Sans"/>
+                <a:ea typeface="Instrument Sans"/>
+                <a:cs typeface="Instrument Sans"/>
+                <a:sym typeface="Instrument Sans"/>
+              </a:rPr>
+              <a:t>市场与竞争</a:t>
+            </a:r>
+            <a:r>
+              <a:rPr lang="zh-CN" sz="850" b="0" i="0" u="none" strike="noStrike" cap="none">
+                <a:solidFill>
+                  <a:srgbClr val="9A978F"/>
+                </a:solidFill>
+                <a:latin typeface="Instrument Sans"/>
+                <a:ea typeface="Instrument Sans"/>
+                <a:cs typeface="Instrument Sans"/>
+                <a:sym typeface="Instrument Sans"/>
+              </a:rPr>
+              <a:t>   </a:t>
+            </a:r>
+            <a:r>
+              <a:rPr lang="zh-CN" sz="850" b="0" i="0" u="none" strike="noStrike" cap="none">
+                <a:solidFill>
+                  <a:srgbClr val="9A978F"/>
+                </a:solidFill>
+                <a:latin typeface="Instrument Sans"/>
+                <a:ea typeface="Instrument Sans"/>
+                <a:cs typeface="Instrument Sans"/>
+                <a:sym typeface="Instrument Sans"/>
+              </a:rPr>
+              <a:t>商业与进展</a:t>
+            </a:r>
+            <a:r>
+              <a:rPr lang="zh-CN" sz="850" b="0" i="0" u="none" strike="noStrike" cap="none">
+                <a:solidFill>
+                  <a:srgbClr val="9A978F"/>
+                </a:solidFill>
+                <a:latin typeface="Instrument Sans"/>
+                <a:ea typeface="Instrument Sans"/>
+                <a:cs typeface="Instrument Sans"/>
+                <a:sym typeface="Instrument Sans"/>
+              </a:rPr>
+              <a:t>   </a:t>
+            </a:r>
+            <a:r>
+              <a:rPr lang="zh-CN" sz="850" b="1" i="0" u="none" strike="noStrike" cap="none">
+                <a:solidFill>
+                  <a:srgbClr val="C2410C"/>
+                </a:solidFill>
+                <a:latin typeface="Instrument Sans"/>
+                <a:ea typeface="Instrument Sans"/>
+                <a:cs typeface="Instrument Sans"/>
+                <a:sym typeface="Instrument Sans"/>
+              </a:rPr>
+              <a:t>计划与融资</a:t>
+            </a:r>
+          </a:p>
+        </p:txBody>
+      </p:sp>
+      <p:sp>
+        <p:nvSpPr>
+          <p:cNvPr id="5003" name="SimReal 5003"/>
+          <p:cNvSpPr txBox="1"/>
+          <p:nvPr/>
+        </p:nvSpPr>
+        <p:spPr>
+          <a:xfrm>
+            <a:off x="548640" y="548640"/>
+            <a:ext cx="11091672" cy="512064"/>
+          </a:xfrm>
+          <a:prstGeom prst="rect">
+            <a:avLst/>
+          </a:prstGeom>
+          <a:noFill/>
+          <a:ln>
+            <a:noFill/>
+          </a:ln>
+        </p:spPr>
+        <p:txBody>
+          <a:bodyPr spcFirstLastPara="1" wrap="square" lIns="0" tIns="0" rIns="0" bIns="0" anchor="t" anchorCtr="0">
+            <a:noAutofit/>
+          </a:bodyPr>
+          <a:lstStyle/>
+          <a:p>
+            <a:pPr marL="0" marR="0" lvl="0" indent="0" algn="l" rtl="0">
+              <a:spcBef>
+                <a:spcPts val="0"/>
+              </a:spcBef>
+              <a:spcAft>
+                <a:spcPts val="0"/>
+              </a:spcAft>
+              <a:buNone/>
+            </a:pPr>
+            <a:r>
+              <a:rPr lang="zh-CN" sz="3000" b="0" i="0" u="none" strike="noStrike" cap="none">
                 <a:solidFill>
                   <a:srgbClr val="111110"/>
                 </a:solidFill>
@@ -36168,232 +37805,47 @@
                 <a:cs typeface="Newsreader"/>
                 <a:sym typeface="Newsreader"/>
               </a:rPr>
-              <a:t>仿真与真实市场的差距</a:t>
-            </a:r>
-          </a:p>
-        </p:txBody>
-      </p:sp>
-      <p:sp>
-        <p:nvSpPr>
-          <p:cNvPr id="5012" name="SimReal 5012"/>
-          <p:cNvSpPr txBox="1"/>
-          <p:nvPr/>
-        </p:nvSpPr>
-        <p:spPr>
-          <a:xfrm>
-            <a:off x="2743200" y="1847088"/>
-            <a:ext cx="3200400" cy="640080"/>
-          </a:xfrm>
-          <a:prstGeom prst="rect">
-            <a:avLst/>
-          </a:prstGeom>
-          <a:noFill/>
-          <a:ln>
-            <a:noFill/>
-          </a:ln>
-        </p:spPr>
-        <p:txBody>
-          <a:bodyPr spcFirstLastPara="1" wrap="square" lIns="0" tIns="0" rIns="0" bIns="0" anchor="ctr" anchorCtr="0">
-            <a:noAutofit/>
-          </a:bodyPr>
-          <a:lstStyle/>
-          <a:p>
-            <a:pPr marL="0" marR="0" lvl="0" indent="0" algn="l" rtl="0">
-              <a:lnSpc>
-                <a:spcPct val="105000"/>
-              </a:lnSpc>
-              <a:spcBef>
-                <a:spcPts val="0"/>
-              </a:spcBef>
-              <a:spcAft>
-                <a:spcPts val="0"/>
-              </a:spcAft>
-              <a:buNone/>
-            </a:pPr>
-            <a:r>
-              <a:rPr lang="zh-CN" sz="1100" b="0" i="0" u="none" strike="noStrike" cap="none">
-                <a:solidFill>
-                  <a:srgbClr val="33322F"/>
-                </a:solidFill>
-                <a:latin typeface="Instrument Sans"/>
-                <a:ea typeface="Instrument Sans"/>
-                <a:cs typeface="Instrument Sans"/>
-                <a:sym typeface="Instrument Sans"/>
-              </a:rPr>
-              <a:t>公开版用竞赛订单簿，回放不计我方订单的冲击</a:t>
-            </a:r>
-          </a:p>
-        </p:txBody>
-      </p:sp>
-      <p:sp>
-        <p:nvSpPr>
-          <p:cNvPr id="5013" name="SimReal 5013"/>
-          <p:cNvSpPr txBox="1"/>
-          <p:nvPr/>
-        </p:nvSpPr>
-        <p:spPr>
-          <a:xfrm>
-            <a:off x="6080760" y="1847088"/>
-            <a:ext cx="3200400" cy="640080"/>
-          </a:xfrm>
-          <a:prstGeom prst="rect">
-            <a:avLst/>
-          </a:prstGeom>
-          <a:noFill/>
-          <a:ln>
-            <a:noFill/>
-          </a:ln>
-        </p:spPr>
-        <p:txBody>
-          <a:bodyPr spcFirstLastPara="1" wrap="square" lIns="0" tIns="0" rIns="0" bIns="0" anchor="ctr" anchorCtr="0">
-            <a:noAutofit/>
-          </a:bodyPr>
-          <a:lstStyle/>
-          <a:p>
-            <a:pPr marL="0" marR="0" lvl="0" indent="0" algn="l" rtl="0">
-              <a:lnSpc>
-                <a:spcPct val="105000"/>
-              </a:lnSpc>
-              <a:spcBef>
-                <a:spcPts val="0"/>
-              </a:spcBef>
-              <a:spcAft>
-                <a:spcPts val="0"/>
-              </a:spcAft>
-              <a:buNone/>
-            </a:pPr>
-            <a:r>
-              <a:rPr lang="zh-CN" sz="1100" b="0" i="0" u="none" strike="noStrike" cap="none">
-                <a:solidFill>
-                  <a:srgbClr val="33322F"/>
-                </a:solidFill>
-                <a:latin typeface="Instrument Sans"/>
-                <a:ea typeface="Instrument Sans"/>
-                <a:cs typeface="Instrument Sans"/>
-                <a:sym typeface="Instrument Sans"/>
-              </a:rPr>
-              <a:t>接入真实行情数据；小资金实盘检验训练效果</a:t>
-            </a:r>
-          </a:p>
-        </p:txBody>
-      </p:sp>
-      <p:sp>
-        <p:nvSpPr>
-          <p:cNvPr id="5014" name="SimReal 5014"/>
-          <p:cNvSpPr txBox="1"/>
-          <p:nvPr/>
-        </p:nvSpPr>
-        <p:spPr>
-          <a:xfrm>
-            <a:off x="9418320" y="1847088"/>
-            <a:ext cx="2221992" cy="640080"/>
-          </a:xfrm>
-          <a:prstGeom prst="rect">
-            <a:avLst/>
-          </a:prstGeom>
-          <a:noFill/>
-          <a:ln>
-            <a:noFill/>
-          </a:ln>
-        </p:spPr>
-        <p:txBody>
-          <a:bodyPr spcFirstLastPara="1" wrap="square" lIns="0" tIns="0" rIns="0" bIns="0" anchor="ctr" anchorCtr="0">
-            <a:noAutofit/>
-          </a:bodyPr>
-          <a:lstStyle/>
-          <a:p>
-            <a:pPr marL="0" marR="0" lvl="0" indent="0" algn="l" rtl="0">
-              <a:lnSpc>
-                <a:spcPct val="105000"/>
-              </a:lnSpc>
-              <a:spcBef>
-                <a:spcPts val="0"/>
-              </a:spcBef>
-              <a:spcAft>
-                <a:spcPts val="0"/>
-              </a:spcAft>
-              <a:buNone/>
-            </a:pPr>
-            <a:r>
-              <a:rPr lang="zh-CN" sz="1100" b="1" i="0" u="none" strike="noStrike" cap="none">
-                <a:solidFill>
-                  <a:srgbClr val="C2410C"/>
-                </a:solidFill>
-                <a:latin typeface="Instrument Sans"/>
-                <a:ea typeface="Instrument Sans"/>
-                <a:cs typeface="Instrument Sans"/>
-                <a:sym typeface="Instrument Sans"/>
-              </a:rPr>
-              <a:t>12个月：小资金实盘</a:t>
-            </a:r>
-          </a:p>
-        </p:txBody>
-      </p:sp>
-      <p:sp>
-        <p:nvSpPr>
-          <p:cNvPr id="5015" name="SimReal 5015"/>
-          <p:cNvSpPr/>
-          <p:nvPr/>
-        </p:nvSpPr>
-        <p:spPr>
-          <a:xfrm>
-            <a:off x="548640" y="2487168"/>
-            <a:ext cx="11091672" cy="9144"/>
-          </a:xfrm>
-          <a:prstGeom prst="rect">
-            <a:avLst/>
-          </a:prstGeom>
-          <a:solidFill>
-            <a:srgbClr val="E2E0DA"/>
-          </a:solidFill>
-          <a:ln>
-            <a:noFill/>
-          </a:ln>
-        </p:spPr>
-        <p:txBody>
-          <a:bodyPr/>
-          <a:lstStyle/>
-          <a:p>
-            <a:endParaRPr/>
-          </a:p>
-        </p:txBody>
-      </p:sp>
-      <p:sp>
-        <p:nvSpPr>
-          <p:cNvPr id="5016" name="SimReal 5016"/>
-          <p:cNvSpPr txBox="1"/>
-          <p:nvPr/>
-        </p:nvSpPr>
-        <p:spPr>
-          <a:xfrm>
-            <a:off x="548640" y="2487168"/>
-            <a:ext cx="2103120" cy="640080"/>
-          </a:xfrm>
-          <a:prstGeom prst="rect">
-            <a:avLst/>
-          </a:prstGeom>
-          <a:noFill/>
-          <a:ln>
-            <a:noFill/>
-          </a:ln>
-        </p:spPr>
-        <p:txBody>
-          <a:bodyPr spcFirstLastPara="1" wrap="square" lIns="0" tIns="0" rIns="0" bIns="0" anchor="ctr" anchorCtr="0">
-            <a:noAutofit/>
-          </a:bodyPr>
-          <a:lstStyle/>
-          <a:p>
-            <a:pPr marL="0" marR="0" lvl="0" indent="0" algn="l" rtl="0">
-              <a:spcBef>
-                <a:spcPts val="0"/>
-              </a:spcBef>
-              <a:spcAft>
-                <a:spcPts val="0"/>
-              </a:spcAft>
-              <a:buNone/>
-            </a:pPr>
-            <a:r>
-              <a:rPr lang="zh-CN" sz="1500" b="0" i="0" u="none" strike="noStrike" cap="none">
+              <a:t>风险与对策</a:t>
+            </a:r>
+          </a:p>
+        </p:txBody>
+      </p:sp>
+      <p:sp>
+        <p:nvSpPr>
+          <p:cNvPr id="5004" name="SimReal 5004"/>
+          <p:cNvSpPr txBox="1"/>
+          <p:nvPr/>
+        </p:nvSpPr>
+        <p:spPr>
+          <a:xfrm>
+            <a:off x="548640" y="1024128"/>
+            <a:ext cx="11091672" cy="329184"/>
+          </a:xfrm>
+          <a:prstGeom prst="rect">
+            <a:avLst/>
+          </a:prstGeom>
+          <a:noFill/>
+          <a:ln>
+            <a:noFill/>
+          </a:ln>
+        </p:spPr>
+        <p:txBody>
+          <a:bodyPr spcFirstLastPara="1" wrap="square" lIns="0" tIns="0" rIns="0" bIns="0" anchor="t" anchorCtr="0">
+            <a:noAutofit/>
+          </a:bodyPr>
+          <a:lstStyle/>
+          <a:p>
+            <a:pPr marL="0" marR="0" lvl="0" indent="0" algn="l" rtl="0">
+              <a:spcBef>
+                <a:spcPts val="0"/>
+              </a:spcBef>
+              <a:spcAft>
+                <a:spcPts val="0"/>
+              </a:spcAft>
+              <a:buNone/>
+            </a:pPr>
+            <a:r>
+              <a:rPr lang="zh-CN" sz="1600" b="0" i="0" u="none" strike="noStrike" cap="none">
                 <a:solidFill>
                   <a:srgbClr val="111110"/>
                 </a:solidFill>
@@ -36402,255 +37854,62 @@
                 <a:cs typeface="Newsreader"/>
                 <a:sym typeface="Newsreader"/>
               </a:rPr>
-              <a:t>数据权属</a:t>
-            </a:r>
-          </a:p>
-        </p:txBody>
-      </p:sp>
-      <p:sp>
-        <p:nvSpPr>
-          <p:cNvPr id="5017" name="SimReal 5017"/>
-          <p:cNvSpPr txBox="1"/>
-          <p:nvPr/>
-        </p:nvSpPr>
-        <p:spPr>
-          <a:xfrm>
-            <a:off x="2743200" y="2487168"/>
-            <a:ext cx="3200400" cy="640080"/>
-          </a:xfrm>
-          <a:prstGeom prst="rect">
-            <a:avLst/>
-          </a:prstGeom>
-          <a:noFill/>
-          <a:ln>
-            <a:noFill/>
-          </a:ln>
-        </p:spPr>
-        <p:txBody>
-          <a:bodyPr spcFirstLastPara="1" wrap="square" lIns="0" tIns="0" rIns="0" bIns="0" anchor="ctr" anchorCtr="0">
-            <a:noAutofit/>
-          </a:bodyPr>
-          <a:lstStyle/>
-          <a:p>
-            <a:pPr marL="0" marR="0" lvl="0" indent="0" algn="l" rtl="0">
-              <a:lnSpc>
-                <a:spcPct val="105000"/>
-              </a:lnSpc>
-              <a:spcBef>
-                <a:spcPts val="0"/>
-              </a:spcBef>
-              <a:spcAft>
-                <a:spcPts val="0"/>
-              </a:spcAft>
-              <a:buNone/>
-            </a:pPr>
-            <a:r>
-              <a:rPr lang="zh-CN" sz="1100" b="0" i="0" u="none" strike="noStrike" cap="none">
-                <a:solidFill>
-                  <a:srgbClr val="33322F"/>
-                </a:solidFill>
-                <a:latin typeface="Instrument Sans"/>
-                <a:ea typeface="Instrument Sans"/>
-                <a:cs typeface="Instrument Sans"/>
-                <a:sym typeface="Instrument Sans"/>
-              </a:rPr>
-              <a:t>公开版用Prosperity开源回测资源，不主张第三方数据权利</a:t>
-            </a:r>
-          </a:p>
-        </p:txBody>
-      </p:sp>
-      <p:sp>
-        <p:nvSpPr>
-          <p:cNvPr id="5018" name="SimReal 5018"/>
-          <p:cNvSpPr txBox="1"/>
-          <p:nvPr/>
-        </p:nvSpPr>
-        <p:spPr>
-          <a:xfrm>
-            <a:off x="6080760" y="2487168"/>
-            <a:ext cx="3200400" cy="640080"/>
-          </a:xfrm>
-          <a:prstGeom prst="rect">
-            <a:avLst/>
-          </a:prstGeom>
-          <a:noFill/>
-          <a:ln>
-            <a:noFill/>
-          </a:ln>
-        </p:spPr>
-        <p:txBody>
-          <a:bodyPr spcFirstLastPara="1" wrap="square" lIns="0" tIns="0" rIns="0" bIns="0" anchor="ctr" anchorCtr="0">
-            <a:noAutofit/>
-          </a:bodyPr>
-          <a:lstStyle/>
-          <a:p>
-            <a:pPr marL="0" marR="0" lvl="0" indent="0" algn="l" rtl="0">
-              <a:lnSpc>
-                <a:spcPct val="105000"/>
-              </a:lnSpc>
-              <a:spcBef>
-                <a:spcPts val="0"/>
-              </a:spcBef>
-              <a:spcAft>
-                <a:spcPts val="0"/>
-              </a:spcAft>
-              <a:buNone/>
-            </a:pPr>
-            <a:r>
-              <a:rPr lang="zh-CN" sz="1100" b="0" i="0" u="none" strike="noStrike" cap="none">
-                <a:solidFill>
-                  <a:srgbClr val="33322F"/>
-                </a:solidFill>
-                <a:latin typeface="Instrument Sans"/>
-                <a:ea typeface="Instrument Sans"/>
-                <a:cs typeface="Instrument Sans"/>
-                <a:sym typeface="Instrument Sans"/>
-              </a:rPr>
-              <a:t>付费版改用自有或授权数据，交付附授权链</a:t>
-            </a:r>
-          </a:p>
-        </p:txBody>
-      </p:sp>
-      <p:sp>
-        <p:nvSpPr>
-          <p:cNvPr id="5019" name="SimReal 5019"/>
-          <p:cNvSpPr txBox="1"/>
-          <p:nvPr/>
-        </p:nvSpPr>
-        <p:spPr>
-          <a:xfrm>
-            <a:off x="9418320" y="2487168"/>
-            <a:ext cx="2221992" cy="640080"/>
-          </a:xfrm>
-          <a:prstGeom prst="rect">
-            <a:avLst/>
-          </a:prstGeom>
-          <a:noFill/>
-          <a:ln>
-            <a:noFill/>
-          </a:ln>
-        </p:spPr>
-        <p:txBody>
-          <a:bodyPr spcFirstLastPara="1" wrap="square" lIns="0" tIns="0" rIns="0" bIns="0" anchor="ctr" anchorCtr="0">
-            <a:noAutofit/>
-          </a:bodyPr>
-          <a:lstStyle/>
-          <a:p>
-            <a:pPr marL="0" marR="0" lvl="0" indent="0" algn="l" rtl="0">
-              <a:lnSpc>
-                <a:spcPct val="105000"/>
-              </a:lnSpc>
-              <a:spcBef>
-                <a:spcPts val="0"/>
-              </a:spcBef>
-              <a:spcAft>
-                <a:spcPts val="0"/>
-              </a:spcAft>
-              <a:buNone/>
-            </a:pPr>
-            <a:r>
-              <a:rPr lang="zh-CN" sz="1100" b="1" i="0" u="none" strike="noStrike" cap="none">
+              <a:t>把风险写在前面：</a:t>
+            </a:r>
+            <a:r>
+              <a:rPr lang="zh-CN" sz="1600" b="0" i="0" u="none" strike="noStrike" cap="none">
                 <a:solidFill>
                   <a:srgbClr val="C2410C"/>
-                </a:solidFill>
-                <a:latin typeface="Instrument Sans"/>
-                <a:ea typeface="Instrument Sans"/>
-                <a:cs typeface="Instrument Sans"/>
-                <a:sym typeface="Instrument Sans"/>
-              </a:rPr>
-              <a:t>首个付费试点前</a:t>
-            </a:r>
-          </a:p>
-        </p:txBody>
-      </p:sp>
-      <p:sp>
-        <p:nvSpPr>
-          <p:cNvPr id="5020" name="SimReal 5020"/>
-          <p:cNvSpPr/>
-          <p:nvPr/>
-        </p:nvSpPr>
-        <p:spPr>
-          <a:xfrm>
-            <a:off x="548640" y="3127248"/>
-            <a:ext cx="11091672" cy="9144"/>
-          </a:xfrm>
-          <a:prstGeom prst="rect">
-            <a:avLst/>
-          </a:prstGeom>
-          <a:solidFill>
-            <a:srgbClr val="E2E0DA"/>
-          </a:solidFill>
-          <a:ln>
-            <a:noFill/>
-          </a:ln>
-        </p:spPr>
-        <p:txBody>
-          <a:bodyPr/>
-          <a:lstStyle/>
-          <a:p>
-            <a:endParaRPr/>
-          </a:p>
-        </p:txBody>
-      </p:sp>
-      <p:sp>
-        <p:nvSpPr>
-          <p:cNvPr id="5021" name="SimReal 5021"/>
-          <p:cNvSpPr txBox="1"/>
-          <p:nvPr/>
-        </p:nvSpPr>
-        <p:spPr>
-          <a:xfrm>
-            <a:off x="548640" y="3127248"/>
-            <a:ext cx="2103120" cy="640080"/>
-          </a:xfrm>
-          <a:prstGeom prst="rect">
-            <a:avLst/>
-          </a:prstGeom>
-          <a:noFill/>
-          <a:ln>
-            <a:noFill/>
-          </a:ln>
-        </p:spPr>
-        <p:txBody>
-          <a:bodyPr spcFirstLastPara="1" wrap="square" lIns="0" tIns="0" rIns="0" bIns="0" anchor="ctr" anchorCtr="0">
-            <a:noAutofit/>
-          </a:bodyPr>
-          <a:lstStyle/>
-          <a:p>
-            <a:pPr marL="0" marR="0" lvl="0" indent="0" algn="l" rtl="0">
-              <a:spcBef>
-                <a:spcPts val="0"/>
-              </a:spcBef>
-              <a:spcAft>
-                <a:spcPts val="0"/>
-              </a:spcAft>
-              <a:buNone/>
-            </a:pPr>
-            <a:r>
-              <a:rPr lang="zh-CN" sz="1500" b="0" i="0" u="none" strike="noStrike" cap="none">
-                <a:solidFill>
-                  <a:srgbClr val="111110"/>
                 </a:solidFill>
                 <a:latin typeface="Newsreader"/>
                 <a:ea typeface="Newsreader"/>
                 <a:cs typeface="Newsreader"/>
                 <a:sym typeface="Newsreader"/>
               </a:rPr>
-              <a:t>统计显著性</a:t>
-            </a:r>
-          </a:p>
-        </p:txBody>
-      </p:sp>
-      <p:sp>
-        <p:nvSpPr>
-          <p:cNvPr id="5022" name="SimReal 5022"/>
-          <p:cNvSpPr txBox="1"/>
-          <p:nvPr/>
-        </p:nvSpPr>
-        <p:spPr>
-          <a:xfrm>
-            <a:off x="2743200" y="3127248"/>
-            <a:ext cx="3200400" cy="640080"/>
+              <a:t>每一条都有对应的验证节点</a:t>
+            </a:r>
+          </a:p>
+        </p:txBody>
+      </p:sp>
+      <p:sp>
+        <p:nvSpPr>
+          <p:cNvPr id="5005" name="SimReal 5005"/>
+          <p:cNvSpPr/>
+          <p:nvPr/>
+        </p:nvSpPr>
+        <p:spPr>
+          <a:xfrm>
+            <a:off x="548640" y="1517904"/>
+            <a:ext cx="11091672" cy="9144"/>
+          </a:xfrm>
+          <a:prstGeom prst="rect">
+            <a:avLst/>
+          </a:prstGeom>
+          <a:solidFill>
+            <a:srgbClr val="111110"/>
+          </a:solidFill>
+          <a:ln>
+            <a:noFill/>
+          </a:ln>
+        </p:spPr>
+        <p:txBody>
+          <a:bodyPr/>
+          <a:lstStyle/>
+          <a:p>
+            <a:endParaRPr/>
+          </a:p>
+        </p:txBody>
+      </p:sp>
+      <p:sp>
+        <p:nvSpPr>
+          <p:cNvPr id="5006" name="SimReal 5006"/>
+          <p:cNvSpPr txBox="1"/>
+          <p:nvPr/>
+        </p:nvSpPr>
+        <p:spPr>
+          <a:xfrm>
+            <a:off x="548640" y="1554480"/>
+            <a:ext cx="2103120" cy="256032"/>
           </a:xfrm>
           <a:prstGeom prst="rect">
             <a:avLst/>
@@ -36667,42 +37926,39 @@
           <a:lstStyle/>
           <a:p>
             <a:pPr marL="0" marR="0" lvl="0" indent="0" algn="l" rtl="0">
-              <a:lnSpc>
-                <a:spcPct val="105000"/>
-              </a:lnSpc>
-              <a:spcBef>
-                <a:spcPts val="0"/>
-              </a:spcBef>
-              <a:spcAft>
-                <a:spcPts val="0"/>
-              </a:spcAft>
-              <a:buNone/>
-            </a:pPr>
-            <a:r>
-              <a:rPr lang="zh-CN" sz="1100" b="0" i="0" u="none" strike="noStrike" cap="none">
-                <a:solidFill>
-                  <a:srgbClr val="33322F"/>
-                </a:solidFill>
-                <a:latin typeface="Instrument Sans"/>
-                <a:ea typeface="Instrument Sans"/>
-                <a:cs typeface="Instrument Sans"/>
-                <a:sym typeface="Instrument Sans"/>
-              </a:rPr>
-              <a:t>每个任务只有1个留出交易日</a:t>
-            </a:r>
-          </a:p>
-        </p:txBody>
-      </p:sp>
-      <p:sp>
-        <p:nvSpPr>
-          <p:cNvPr id="5023" name="SimReal 5023"/>
-          <p:cNvSpPr txBox="1"/>
-          <p:nvPr/>
-        </p:nvSpPr>
-        <p:spPr>
-          <a:xfrm>
-            <a:off x="6080760" y="3127248"/>
-            <a:ext cx="3200400" cy="640080"/>
+              <a:spcBef>
+                <a:spcPts val="0"/>
+              </a:spcBef>
+              <a:spcAft>
+                <a:spcPts val="0"/>
+              </a:spcAft>
+              <a:buNone/>
+            </a:pPr>
+            <a:r>
+              <a:rPr lang="zh-CN" sz="950" b="0" i="0" u="none" strike="noStrike" cap="none">
+                <a:solidFill>
+                  <a:srgbClr val="6E6C66"/>
+                </a:solidFill>
+                <a:latin typeface="IBM Plex Mono"/>
+                <a:ea typeface="IBM Plex Mono"/>
+                <a:cs typeface="IBM Plex Mono"/>
+                <a:sym typeface="IBM Plex Mono"/>
+              </a:rPr>
+              <a:t>风险</a:t>
+            </a:r>
+          </a:p>
+        </p:txBody>
+      </p:sp>
+      <p:sp>
+        <p:nvSpPr>
+          <p:cNvPr id="5007" name="SimReal 5007"/>
+          <p:cNvSpPr txBox="1"/>
+          <p:nvPr/>
+        </p:nvSpPr>
+        <p:spPr>
+          <a:xfrm>
+            <a:off x="2743200" y="1554480"/>
+            <a:ext cx="3200400" cy="256032"/>
           </a:xfrm>
           <a:prstGeom prst="rect">
             <a:avLst/>
@@ -36719,42 +37975,39 @@
           <a:lstStyle/>
           <a:p>
             <a:pPr marL="0" marR="0" lvl="0" indent="0" algn="l" rtl="0">
-              <a:lnSpc>
-                <a:spcPct val="105000"/>
-              </a:lnSpc>
-              <a:spcBef>
-                <a:spcPts val="0"/>
-              </a:spcBef>
-              <a:spcAft>
-                <a:spcPts val="0"/>
-              </a:spcAft>
-              <a:buNone/>
-            </a:pPr>
-            <a:r>
-              <a:rPr lang="zh-CN" sz="1100" b="0" i="0" u="none" strike="noStrike" cap="none">
-                <a:solidFill>
-                  <a:srgbClr val="33322F"/>
-                </a:solidFill>
-                <a:latin typeface="Instrument Sans"/>
-                <a:ea typeface="Instrument Sans"/>
-                <a:cs typeface="Instrument Sans"/>
-                <a:sym typeface="Instrument Sans"/>
-              </a:rPr>
-              <a:t>多种子、储备任务、跨领域复验</a:t>
-            </a:r>
-          </a:p>
-        </p:txBody>
-      </p:sp>
-      <p:sp>
-        <p:nvSpPr>
-          <p:cNvPr id="5024" name="SimReal 5024"/>
-          <p:cNvSpPr txBox="1"/>
-          <p:nvPr/>
-        </p:nvSpPr>
-        <p:spPr>
-          <a:xfrm>
-            <a:off x="9418320" y="3127248"/>
-            <a:ext cx="2221992" cy="640080"/>
+              <a:spcBef>
+                <a:spcPts val="0"/>
+              </a:spcBef>
+              <a:spcAft>
+                <a:spcPts val="0"/>
+              </a:spcAft>
+              <a:buNone/>
+            </a:pPr>
+            <a:r>
+              <a:rPr lang="zh-CN" sz="950" b="0" i="0" u="none" strike="noStrike" cap="none">
+                <a:solidFill>
+                  <a:srgbClr val="6E6C66"/>
+                </a:solidFill>
+                <a:latin typeface="IBM Plex Mono"/>
+                <a:ea typeface="IBM Plex Mono"/>
+                <a:cs typeface="IBM Plex Mono"/>
+                <a:sym typeface="IBM Plex Mono"/>
+              </a:rPr>
+              <a:t>现状</a:t>
+            </a:r>
+          </a:p>
+        </p:txBody>
+      </p:sp>
+      <p:sp>
+        <p:nvSpPr>
+          <p:cNvPr id="5008" name="SimReal 5008"/>
+          <p:cNvSpPr txBox="1"/>
+          <p:nvPr/>
+        </p:nvSpPr>
+        <p:spPr>
+          <a:xfrm>
+            <a:off x="6080760" y="1554480"/>
+            <a:ext cx="3200400" cy="256032"/>
           </a:xfrm>
           <a:prstGeom prst="rect">
             <a:avLst/>
@@ -36771,41 +38024,87 @@
           <a:lstStyle/>
           <a:p>
             <a:pPr marL="0" marR="0" lvl="0" indent="0" algn="l" rtl="0">
-              <a:lnSpc>
-                <a:spcPct val="105000"/>
-              </a:lnSpc>
-              <a:spcBef>
-                <a:spcPts val="0"/>
-              </a:spcBef>
-              <a:spcAft>
-                <a:spcPts val="0"/>
-              </a:spcAft>
-              <a:buNone/>
-            </a:pPr>
-            <a:r>
-              <a:rPr lang="zh-CN" sz="1100" b="1" i="0" u="none" strike="noStrike" cap="none">
-                <a:solidFill>
-                  <a:srgbClr val="C2410C"/>
-                </a:solidFill>
-                <a:latin typeface="Instrument Sans"/>
-                <a:ea typeface="Instrument Sans"/>
-                <a:cs typeface="Instrument Sans"/>
-                <a:sym typeface="Instrument Sans"/>
-              </a:rPr>
-              <a:t>3个月：报告置信区间</a:t>
-            </a:r>
-          </a:p>
-        </p:txBody>
-      </p:sp>
-      <p:sp>
-        <p:nvSpPr>
-          <p:cNvPr id="5025" name="SimReal 5025"/>
+              <a:spcBef>
+                <a:spcPts val="0"/>
+              </a:spcBef>
+              <a:spcAft>
+                <a:spcPts val="0"/>
+              </a:spcAft>
+              <a:buNone/>
+            </a:pPr>
+            <a:r>
+              <a:rPr lang="zh-CN" sz="950" b="0" i="0" u="none" strike="noStrike" cap="none">
+                <a:solidFill>
+                  <a:srgbClr val="6E6C66"/>
+                </a:solidFill>
+                <a:latin typeface="IBM Plex Mono"/>
+                <a:ea typeface="IBM Plex Mono"/>
+                <a:cs typeface="IBM Plex Mono"/>
+                <a:sym typeface="IBM Plex Mono"/>
+              </a:rPr>
+              <a:t>对策</a:t>
+            </a:r>
+          </a:p>
+        </p:txBody>
+      </p:sp>
+      <p:sp>
+        <p:nvSpPr>
+          <p:cNvPr id="5009" name="SimReal 5009"/>
+          <p:cNvSpPr txBox="1"/>
+          <p:nvPr/>
+        </p:nvSpPr>
+        <p:spPr>
+          <a:xfrm>
+            <a:off x="9418320" y="1554480"/>
+            <a:ext cx="2221992" cy="256032"/>
+          </a:xfrm>
+          <a:prstGeom prst="rect">
+            <a:avLst/>
+          </a:prstGeom>
+          <a:noFill/>
+          <a:ln>
+            <a:noFill/>
+          </a:ln>
+        </p:spPr>
+        <p:txBody>
+          <a:bodyPr spcFirstLastPara="1" wrap="square" lIns="0" tIns="0" rIns="0" bIns="0" anchor="ctr" anchorCtr="0">
+            <a:noAutofit/>
+          </a:bodyPr>
+          <a:lstStyle/>
+          <a:p>
+            <a:pPr marL="0" marR="0" lvl="0" indent="0" algn="l" rtl="0">
+              <a:spcBef>
+                <a:spcPts val="0"/>
+              </a:spcBef>
+              <a:spcAft>
+                <a:spcPts val="0"/>
+              </a:spcAft>
+              <a:buNone/>
+            </a:pPr>
+            <a:r>
+              <a:rPr lang="zh-CN" sz="950" b="0" i="0" u="none" strike="noStrike" cap="none">
+                <a:solidFill>
+                  <a:srgbClr val="6E6C66"/>
+                </a:solidFill>
+                <a:latin typeface="IBM Plex Mono"/>
+                <a:ea typeface="IBM Plex Mono"/>
+                <a:cs typeface="IBM Plex Mono"/>
+                <a:sym typeface="IBM Plex Mono"/>
+              </a:rPr>
+              <a:t>验证节点</a:t>
+            </a:r>
+          </a:p>
+        </p:txBody>
+      </p:sp>
+      <p:sp>
+        <p:nvSpPr>
+          <p:cNvPr id="5010" name="SimReal 5010"/>
           <p:cNvSpPr/>
           <p:nvPr/>
         </p:nvSpPr>
         <p:spPr>
           <a:xfrm>
-            <a:off x="548640" y="3767328"/>
+            <a:off x="548640" y="1847088"/>
             <a:ext cx="11091672" cy="9144"/>
           </a:xfrm>
           <a:prstGeom prst="rect">
@@ -36828,13 +38127,13 @@
       </p:sp>
       <p:sp>
         <p:nvSpPr>
-          <p:cNvPr id="5026" name="SimReal 5026"/>
-          <p:cNvSpPr txBox="1"/>
-          <p:nvPr/>
-        </p:nvSpPr>
-        <p:spPr>
-          <a:xfrm>
-            <a:off x="548640" y="3767328"/>
+          <p:cNvPr id="5011" name="SimReal 5011"/>
+          <p:cNvSpPr txBox="1"/>
+          <p:nvPr/>
+        </p:nvSpPr>
+        <p:spPr>
+          <a:xfrm>
+            <a:off x="548640" y="1847088"/>
             <a:ext cx="2103120" cy="640080"/>
           </a:xfrm>
           <a:prstGeom prst="rect">
@@ -36870,20 +38169,20 @@
                 <a:cs typeface="Newsreader"/>
                 <a:sym typeface="Newsreader"/>
               </a:rPr>
-              <a:t>买家集中</a:t>
-            </a:r>
-          </a:p>
-        </p:txBody>
-      </p:sp>
-      <p:sp>
-        <p:nvSpPr>
-          <p:cNvPr id="5027" name="SimReal 5027"/>
-          <p:cNvSpPr txBox="1"/>
-          <p:nvPr/>
-        </p:nvSpPr>
-        <p:spPr>
-          <a:xfrm>
-            <a:off x="2743200" y="3767328"/>
+              <a:t>仿真与真实市场的差距</a:t>
+            </a:r>
+          </a:p>
+        </p:txBody>
+      </p:sp>
+      <p:sp>
+        <p:nvSpPr>
+          <p:cNvPr id="5012" name="SimReal 5012"/>
+          <p:cNvSpPr txBox="1"/>
+          <p:nvPr/>
+        </p:nvSpPr>
+        <p:spPr>
+          <a:xfrm>
+            <a:off x="2743200" y="1847088"/>
             <a:ext cx="3200400" cy="640080"/>
           </a:xfrm>
           <a:prstGeom prst="rect">
@@ -36922,20 +38221,20 @@
                 <a:cs typeface="Instrument Sans"/>
                 <a:sym typeface="Instrument Sans"/>
               </a:rPr>
-              <a:t>约20家实验室占大部分需求</a:t>
-            </a:r>
-          </a:p>
-        </p:txBody>
-      </p:sp>
-      <p:sp>
-        <p:nvSpPr>
-          <p:cNvPr id="5028" name="SimReal 5028"/>
-          <p:cNvSpPr txBox="1"/>
-          <p:nvPr/>
-        </p:nvSpPr>
-        <p:spPr>
-          <a:xfrm>
-            <a:off x="6080760" y="3767328"/>
+              <a:t>公开版用竞赛订单簿，回放不计我方订单的冲击</a:t>
+            </a:r>
+          </a:p>
+        </p:txBody>
+      </p:sp>
+      <p:sp>
+        <p:nvSpPr>
+          <p:cNvPr id="5013" name="SimReal 5013"/>
+          <p:cNvSpPr txBox="1"/>
+          <p:nvPr/>
+        </p:nvSpPr>
+        <p:spPr>
+          <a:xfrm>
+            <a:off x="6080760" y="1847088"/>
             <a:ext cx="3200400" cy="640080"/>
           </a:xfrm>
           <a:prstGeom prst="rect">
@@ -36974,20 +38273,20 @@
                 <a:cs typeface="Instrument Sans"/>
                 <a:sym typeface="Instrument Sans"/>
               </a:rPr>
-              <a:t>同一环境授权多家；延伸到交易机构</a:t>
-            </a:r>
-          </a:p>
-        </p:txBody>
-      </p:sp>
-      <p:sp>
-        <p:nvSpPr>
-          <p:cNvPr id="5029" name="SimReal 5029"/>
-          <p:cNvSpPr txBox="1"/>
-          <p:nvPr/>
-        </p:nvSpPr>
-        <p:spPr>
-          <a:xfrm>
-            <a:off x="9418320" y="3767328"/>
+              <a:t>接入真实行情数据；小资金实盘检验训练效果</a:t>
+            </a:r>
+          </a:p>
+        </p:txBody>
+      </p:sp>
+      <p:sp>
+        <p:nvSpPr>
+          <p:cNvPr id="5014" name="SimReal 5014"/>
+          <p:cNvSpPr txBox="1"/>
+          <p:nvPr/>
+        </p:nvSpPr>
+        <p:spPr>
+          <a:xfrm>
+            <a:off x="9418320" y="1847088"/>
             <a:ext cx="2221992" cy="640080"/>
           </a:xfrm>
           <a:prstGeom prst="rect">
@@ -37026,20 +38325,20 @@
                 <a:cs typeface="Instrument Sans"/>
                 <a:sym typeface="Instrument Sans"/>
               </a:rPr>
-              <a:t>6个月：第2家授权</a:t>
-            </a:r>
-          </a:p>
-        </p:txBody>
-      </p:sp>
-      <p:sp>
-        <p:nvSpPr>
-          <p:cNvPr id="5030" name="SimReal 5030"/>
+              <a:t>12个月：小资金实盘</a:t>
+            </a:r>
+          </a:p>
+        </p:txBody>
+      </p:sp>
+      <p:sp>
+        <p:nvSpPr>
+          <p:cNvPr id="5015" name="SimReal 5015"/>
           <p:cNvSpPr/>
           <p:nvPr/>
         </p:nvSpPr>
         <p:spPr>
           <a:xfrm>
-            <a:off x="548640" y="4407408"/>
+            <a:off x="548640" y="2487168"/>
             <a:ext cx="11091672" cy="9144"/>
           </a:xfrm>
           <a:prstGeom prst="rect">
@@ -37062,13 +38361,13 @@
       </p:sp>
       <p:sp>
         <p:nvSpPr>
-          <p:cNvPr id="5031" name="SimReal 5031"/>
-          <p:cNvSpPr txBox="1"/>
-          <p:nvPr/>
-        </p:nvSpPr>
-        <p:spPr>
-          <a:xfrm>
-            <a:off x="548640" y="4407408"/>
+          <p:cNvPr id="5016" name="SimReal 5016"/>
+          <p:cNvSpPr txBox="1"/>
+          <p:nvPr/>
+        </p:nvSpPr>
+        <p:spPr>
+          <a:xfrm>
+            <a:off x="548640" y="2487168"/>
             <a:ext cx="2103120" cy="640080"/>
           </a:xfrm>
           <a:prstGeom prst="rect">
@@ -37104,20 +38403,20 @@
                 <a:cs typeface="Newsreader"/>
                 <a:sym typeface="Newsreader"/>
               </a:rPr>
-              <a:t>跨境合规</a:t>
-            </a:r>
-          </a:p>
-        </p:txBody>
-      </p:sp>
-      <p:sp>
-        <p:nvSpPr>
-          <p:cNvPr id="5032" name="SimReal 5032"/>
-          <p:cNvSpPr txBox="1"/>
-          <p:nvPr/>
-        </p:nvSpPr>
-        <p:spPr>
-          <a:xfrm>
-            <a:off x="2743200" y="4407408"/>
+              <a:t>数据权属</a:t>
+            </a:r>
+          </a:p>
+        </p:txBody>
+      </p:sp>
+      <p:sp>
+        <p:nvSpPr>
+          <p:cNvPr id="5017" name="SimReal 5017"/>
+          <p:cNvSpPr txBox="1"/>
+          <p:nvPr/>
+        </p:nvSpPr>
+        <p:spPr>
+          <a:xfrm>
+            <a:off x="2743200" y="2487168"/>
             <a:ext cx="3200400" cy="640080"/>
           </a:xfrm>
           <a:prstGeom prst="rect">
@@ -37156,20 +38455,20 @@
                 <a:cs typeface="Instrument Sans"/>
                 <a:sym typeface="Instrument Sans"/>
               </a:rPr>
-              <a:t>中国团队，服务中美实验室</a:t>
-            </a:r>
-          </a:p>
-        </p:txBody>
-      </p:sp>
-      <p:sp>
-        <p:nvSpPr>
-          <p:cNvPr id="5033" name="SimReal 5033"/>
-          <p:cNvSpPr txBox="1"/>
-          <p:nvPr/>
-        </p:nvSpPr>
-        <p:spPr>
-          <a:xfrm>
-            <a:off x="6080760" y="4407408"/>
+              <a:t>公开版用Prosperity开源回测资源，不主张第三方数据权利</a:t>
+            </a:r>
+          </a:p>
+        </p:txBody>
+      </p:sp>
+      <p:sp>
+        <p:nvSpPr>
+          <p:cNvPr id="5018" name="SimReal 5018"/>
+          <p:cNvSpPr txBox="1"/>
+          <p:nvPr/>
+        </p:nvSpPr>
+        <p:spPr>
+          <a:xfrm>
+            <a:off x="6080760" y="2487168"/>
             <a:ext cx="3200400" cy="640080"/>
           </a:xfrm>
           <a:prstGeom prst="rect">
@@ -37208,20 +38507,20 @@
                 <a:cs typeface="Instrument Sans"/>
                 <a:sym typeface="Instrument Sans"/>
               </a:rPr>
-              <a:t>数据按客户所在地区分开存储与交付</a:t>
-            </a:r>
-          </a:p>
-        </p:txBody>
-      </p:sp>
-      <p:sp>
-        <p:nvSpPr>
-          <p:cNvPr id="5034" name="SimReal 5034"/>
-          <p:cNvSpPr txBox="1"/>
-          <p:nvPr/>
-        </p:nvSpPr>
-        <p:spPr>
-          <a:xfrm>
-            <a:off x="9418320" y="4407408"/>
+              <a:t>付费版改用自有或授权数据，交付附授权链</a:t>
+            </a:r>
+          </a:p>
+        </p:txBody>
+      </p:sp>
+      <p:sp>
+        <p:nvSpPr>
+          <p:cNvPr id="5019" name="SimReal 5019"/>
+          <p:cNvSpPr txBox="1"/>
+          <p:nvPr/>
+        </p:nvSpPr>
+        <p:spPr>
+          <a:xfrm>
+            <a:off x="9418320" y="2487168"/>
             <a:ext cx="2221992" cy="640080"/>
           </a:xfrm>
           <a:prstGeom prst="rect">
@@ -37260,20 +38559,20 @@
                 <a:cs typeface="Instrument Sans"/>
                 <a:sym typeface="Instrument Sans"/>
               </a:rPr>
-              <a:t>【待补：主体与架构】</a:t>
-            </a:r>
-          </a:p>
-        </p:txBody>
-      </p:sp>
-      <p:sp>
-        <p:nvSpPr>
-          <p:cNvPr id="5035" name="SimReal 5035"/>
+              <a:t>首个付费试点前</a:t>
+            </a:r>
+          </a:p>
+        </p:txBody>
+      </p:sp>
+      <p:sp>
+        <p:nvSpPr>
+          <p:cNvPr id="5020" name="SimReal 5020"/>
           <p:cNvSpPr/>
           <p:nvPr/>
         </p:nvSpPr>
         <p:spPr>
           <a:xfrm>
-            <a:off x="548640" y="5047488"/>
+            <a:off x="548640" y="3127248"/>
             <a:ext cx="11091672" cy="9144"/>
           </a:xfrm>
           <a:prstGeom prst="rect">
@@ -37296,14 +38595,14 @@
       </p:sp>
       <p:sp>
         <p:nvSpPr>
-          <p:cNvPr id="5036" name="SimReal 5036"/>
-          <p:cNvSpPr txBox="1"/>
-          <p:nvPr/>
-        </p:nvSpPr>
-        <p:spPr>
-          <a:xfrm>
-            <a:off x="548640" y="5349240"/>
-            <a:ext cx="11091672" cy="420624"/>
+          <p:cNvPr id="5021" name="SimReal 5021"/>
+          <p:cNvSpPr txBox="1"/>
+          <p:nvPr/>
+        </p:nvSpPr>
+        <p:spPr>
+          <a:xfrm>
+            <a:off x="548640" y="3127248"/>
+            <a:ext cx="2103120" cy="640080"/>
           </a:xfrm>
           <a:prstGeom prst="rect">
             <a:avLst/>
@@ -37329,7 +38628,7 @@
               <a:buNone/>
             </a:pPr>
             <a:r>
-              <a:rPr lang="zh-CN" sz="2000" b="0" i="0" u="none" strike="noStrike" cap="none">
+              <a:rPr lang="zh-CN" sz="1500" b="0" i="0" u="none" strike="noStrike" cap="none">
                 <a:solidFill>
                   <a:srgbClr val="111110"/>
                 </a:solidFill>
@@ -37338,22 +38637,466 @@
                 <a:cs typeface="Newsreader"/>
                 <a:sym typeface="Newsreader"/>
               </a:rPr>
-              <a:t>不过度美化：</a:t>
-            </a:r>
-            <a:r>
-              <a:rPr lang="zh-CN" sz="2000" b="0" i="0" u="none" strike="noStrike" cap="none">
+              <a:t>统计显著性</a:t>
+            </a:r>
+          </a:p>
+        </p:txBody>
+      </p:sp>
+      <p:sp>
+        <p:nvSpPr>
+          <p:cNvPr id="5022" name="SimReal 5022"/>
+          <p:cNvSpPr txBox="1"/>
+          <p:nvPr/>
+        </p:nvSpPr>
+        <p:spPr>
+          <a:xfrm>
+            <a:off x="2743200" y="3127248"/>
+            <a:ext cx="3200400" cy="640080"/>
+          </a:xfrm>
+          <a:prstGeom prst="rect">
+            <a:avLst/>
+          </a:prstGeom>
+          <a:noFill/>
+          <a:ln>
+            <a:noFill/>
+          </a:ln>
+        </p:spPr>
+        <p:txBody>
+          <a:bodyPr spcFirstLastPara="1" wrap="square" lIns="0" tIns="0" rIns="0" bIns="0" anchor="ctr" anchorCtr="0">
+            <a:noAutofit/>
+          </a:bodyPr>
+          <a:lstStyle/>
+          <a:p>
+            <a:pPr marL="0" marR="0" lvl="0" indent="0" algn="l" rtl="0">
+              <a:lnSpc>
+                <a:spcPct val="105000"/>
+              </a:lnSpc>
+              <a:spcBef>
+                <a:spcPts val="0"/>
+              </a:spcBef>
+              <a:spcAft>
+                <a:spcPts val="0"/>
+              </a:spcAft>
+              <a:buNone/>
+            </a:pPr>
+            <a:r>
+              <a:rPr lang="zh-CN" sz="1100" b="0" i="0" u="none" strike="noStrike" cap="none">
+                <a:solidFill>
+                  <a:srgbClr val="33322F"/>
+                </a:solidFill>
+                <a:latin typeface="Instrument Sans"/>
+                <a:ea typeface="Instrument Sans"/>
+                <a:cs typeface="Instrument Sans"/>
+                <a:sym typeface="Instrument Sans"/>
+              </a:rPr>
+              <a:t>每个任务只有1个留出交易日</a:t>
+            </a:r>
+          </a:p>
+        </p:txBody>
+      </p:sp>
+      <p:sp>
+        <p:nvSpPr>
+          <p:cNvPr id="5023" name="SimReal 5023"/>
+          <p:cNvSpPr txBox="1"/>
+          <p:nvPr/>
+        </p:nvSpPr>
+        <p:spPr>
+          <a:xfrm>
+            <a:off x="6080760" y="3127248"/>
+            <a:ext cx="3200400" cy="640080"/>
+          </a:xfrm>
+          <a:prstGeom prst="rect">
+            <a:avLst/>
+          </a:prstGeom>
+          <a:noFill/>
+          <a:ln>
+            <a:noFill/>
+          </a:ln>
+        </p:spPr>
+        <p:txBody>
+          <a:bodyPr spcFirstLastPara="1" wrap="square" lIns="0" tIns="0" rIns="0" bIns="0" anchor="ctr" anchorCtr="0">
+            <a:noAutofit/>
+          </a:bodyPr>
+          <a:lstStyle/>
+          <a:p>
+            <a:pPr marL="0" marR="0" lvl="0" indent="0" algn="l" rtl="0">
+              <a:lnSpc>
+                <a:spcPct val="105000"/>
+              </a:lnSpc>
+              <a:spcBef>
+                <a:spcPts val="0"/>
+              </a:spcBef>
+              <a:spcAft>
+                <a:spcPts val="0"/>
+              </a:spcAft>
+              <a:buNone/>
+            </a:pPr>
+            <a:r>
+              <a:rPr lang="zh-CN" sz="1100" b="0" i="0" u="none" strike="noStrike" cap="none">
+                <a:solidFill>
+                  <a:srgbClr val="33322F"/>
+                </a:solidFill>
+                <a:latin typeface="Instrument Sans"/>
+                <a:ea typeface="Instrument Sans"/>
+                <a:cs typeface="Instrument Sans"/>
+                <a:sym typeface="Instrument Sans"/>
+              </a:rPr>
+              <a:t>多种子、储备任务、跨领域复验</a:t>
+            </a:r>
+          </a:p>
+        </p:txBody>
+      </p:sp>
+      <p:sp>
+        <p:nvSpPr>
+          <p:cNvPr id="5024" name="SimReal 5024"/>
+          <p:cNvSpPr txBox="1"/>
+          <p:nvPr/>
+        </p:nvSpPr>
+        <p:spPr>
+          <a:xfrm>
+            <a:off x="9418320" y="3127248"/>
+            <a:ext cx="2221992" cy="640080"/>
+          </a:xfrm>
+          <a:prstGeom prst="rect">
+            <a:avLst/>
+          </a:prstGeom>
+          <a:noFill/>
+          <a:ln>
+            <a:noFill/>
+          </a:ln>
+        </p:spPr>
+        <p:txBody>
+          <a:bodyPr spcFirstLastPara="1" wrap="square" lIns="0" tIns="0" rIns="0" bIns="0" anchor="ctr" anchorCtr="0">
+            <a:noAutofit/>
+          </a:bodyPr>
+          <a:lstStyle/>
+          <a:p>
+            <a:pPr marL="0" marR="0" lvl="0" indent="0" algn="l" rtl="0">
+              <a:lnSpc>
+                <a:spcPct val="105000"/>
+              </a:lnSpc>
+              <a:spcBef>
+                <a:spcPts val="0"/>
+              </a:spcBef>
+              <a:spcAft>
+                <a:spcPts val="0"/>
+              </a:spcAft>
+              <a:buNone/>
+            </a:pPr>
+            <a:r>
+              <a:rPr lang="zh-CN" sz="1100" b="1" i="0" u="none" strike="noStrike" cap="none">
                 <a:solidFill>
                   <a:srgbClr val="C2410C"/>
+                </a:solidFill>
+                <a:latin typeface="Instrument Sans"/>
+                <a:ea typeface="Instrument Sans"/>
+                <a:cs typeface="Instrument Sans"/>
+                <a:sym typeface="Instrument Sans"/>
+              </a:rPr>
+              <a:t>3个月：报告置信区间</a:t>
+            </a:r>
+          </a:p>
+        </p:txBody>
+      </p:sp>
+      <p:sp>
+        <p:nvSpPr>
+          <p:cNvPr id="5025" name="SimReal 5025"/>
+          <p:cNvSpPr/>
+          <p:nvPr/>
+        </p:nvSpPr>
+        <p:spPr>
+          <a:xfrm>
+            <a:off x="548640" y="3767328"/>
+            <a:ext cx="11091672" cy="9144"/>
+          </a:xfrm>
+          <a:prstGeom prst="rect">
+            <a:avLst/>
+          </a:prstGeom>
+          <a:solidFill>
+            <a:srgbClr val="E2E0DA"/>
+          </a:solidFill>
+          <a:ln>
+            <a:noFill/>
+          </a:ln>
+        </p:spPr>
+        <p:txBody>
+          <a:bodyPr/>
+          <a:lstStyle/>
+          <a:p>
+            <a:endParaRPr/>
+          </a:p>
+        </p:txBody>
+      </p:sp>
+      <p:sp>
+        <p:nvSpPr>
+          <p:cNvPr id="5026" name="SimReal 5026"/>
+          <p:cNvSpPr txBox="1"/>
+          <p:nvPr/>
+        </p:nvSpPr>
+        <p:spPr>
+          <a:xfrm>
+            <a:off x="548640" y="3767328"/>
+            <a:ext cx="2103120" cy="640080"/>
+          </a:xfrm>
+          <a:prstGeom prst="rect">
+            <a:avLst/>
+          </a:prstGeom>
+          <a:noFill/>
+          <a:ln>
+            <a:noFill/>
+          </a:ln>
+        </p:spPr>
+        <p:txBody>
+          <a:bodyPr spcFirstLastPara="1" wrap="square" lIns="0" tIns="0" rIns="0" bIns="0" anchor="ctr" anchorCtr="0">
+            <a:noAutofit/>
+          </a:bodyPr>
+          <a:lstStyle/>
+          <a:p>
+            <a:pPr marL="0" marR="0" lvl="0" indent="0" algn="l" rtl="0">
+              <a:spcBef>
+                <a:spcPts val="0"/>
+              </a:spcBef>
+              <a:spcAft>
+                <a:spcPts val="0"/>
+              </a:spcAft>
+              <a:buNone/>
+            </a:pPr>
+            <a:r>
+              <a:rPr lang="zh-CN" sz="1500" b="0" i="0" u="none" strike="noStrike" cap="none">
+                <a:solidFill>
+                  <a:srgbClr val="111110"/>
                 </a:solidFill>
                 <a:latin typeface="Newsreader"/>
                 <a:ea typeface="Newsreader"/>
                 <a:cs typeface="Newsreader"/>
                 <a:sym typeface="Newsreader"/>
               </a:rPr>
-              <a:t>每个数字都能在尽调里复现</a:t>
-            </a:r>
-            <a:r>
-              <a:rPr lang="zh-CN" sz="2000" b="0" i="0" u="none" strike="noStrike" cap="none">
+              <a:t>买家集中</a:t>
+            </a:r>
+          </a:p>
+        </p:txBody>
+      </p:sp>
+      <p:sp>
+        <p:nvSpPr>
+          <p:cNvPr id="5027" name="SimReal 5027"/>
+          <p:cNvSpPr txBox="1"/>
+          <p:nvPr/>
+        </p:nvSpPr>
+        <p:spPr>
+          <a:xfrm>
+            <a:off x="2743200" y="3767328"/>
+            <a:ext cx="3200400" cy="640080"/>
+          </a:xfrm>
+          <a:prstGeom prst="rect">
+            <a:avLst/>
+          </a:prstGeom>
+          <a:noFill/>
+          <a:ln>
+            <a:noFill/>
+          </a:ln>
+        </p:spPr>
+        <p:txBody>
+          <a:bodyPr spcFirstLastPara="1" wrap="square" lIns="0" tIns="0" rIns="0" bIns="0" anchor="ctr" anchorCtr="0">
+            <a:noAutofit/>
+          </a:bodyPr>
+          <a:lstStyle/>
+          <a:p>
+            <a:pPr marL="0" marR="0" lvl="0" indent="0" algn="l" rtl="0">
+              <a:lnSpc>
+                <a:spcPct val="105000"/>
+              </a:lnSpc>
+              <a:spcBef>
+                <a:spcPts val="0"/>
+              </a:spcBef>
+              <a:spcAft>
+                <a:spcPts val="0"/>
+              </a:spcAft>
+              <a:buNone/>
+            </a:pPr>
+            <a:r>
+              <a:rPr lang="zh-CN" sz="1100" b="0" i="0" u="none" strike="noStrike" cap="none">
+                <a:solidFill>
+                  <a:srgbClr val="33322F"/>
+                </a:solidFill>
+                <a:latin typeface="Instrument Sans"/>
+                <a:ea typeface="Instrument Sans"/>
+                <a:cs typeface="Instrument Sans"/>
+                <a:sym typeface="Instrument Sans"/>
+              </a:rPr>
+              <a:t>约20家实验室占大部分需求</a:t>
+            </a:r>
+          </a:p>
+        </p:txBody>
+      </p:sp>
+      <p:sp>
+        <p:nvSpPr>
+          <p:cNvPr id="5028" name="SimReal 5028"/>
+          <p:cNvSpPr txBox="1"/>
+          <p:nvPr/>
+        </p:nvSpPr>
+        <p:spPr>
+          <a:xfrm>
+            <a:off x="6080760" y="3767328"/>
+            <a:ext cx="3200400" cy="640080"/>
+          </a:xfrm>
+          <a:prstGeom prst="rect">
+            <a:avLst/>
+          </a:prstGeom>
+          <a:noFill/>
+          <a:ln>
+            <a:noFill/>
+          </a:ln>
+        </p:spPr>
+        <p:txBody>
+          <a:bodyPr spcFirstLastPara="1" wrap="square" lIns="0" tIns="0" rIns="0" bIns="0" anchor="ctr" anchorCtr="0">
+            <a:noAutofit/>
+          </a:bodyPr>
+          <a:lstStyle/>
+          <a:p>
+            <a:pPr marL="0" marR="0" lvl="0" indent="0" algn="l" rtl="0">
+              <a:lnSpc>
+                <a:spcPct val="105000"/>
+              </a:lnSpc>
+              <a:spcBef>
+                <a:spcPts val="0"/>
+              </a:spcBef>
+              <a:spcAft>
+                <a:spcPts val="0"/>
+              </a:spcAft>
+              <a:buNone/>
+            </a:pPr>
+            <a:r>
+              <a:rPr lang="zh-CN" sz="1100" b="0" i="0" u="none" strike="noStrike" cap="none">
+                <a:solidFill>
+                  <a:srgbClr val="33322F"/>
+                </a:solidFill>
+                <a:latin typeface="Instrument Sans"/>
+                <a:ea typeface="Instrument Sans"/>
+                <a:cs typeface="Instrument Sans"/>
+                <a:sym typeface="Instrument Sans"/>
+              </a:rPr>
+              <a:t>同一环境授权多家；延伸到交易机构</a:t>
+            </a:r>
+          </a:p>
+        </p:txBody>
+      </p:sp>
+      <p:sp>
+        <p:nvSpPr>
+          <p:cNvPr id="5029" name="SimReal 5029"/>
+          <p:cNvSpPr txBox="1"/>
+          <p:nvPr/>
+        </p:nvSpPr>
+        <p:spPr>
+          <a:xfrm>
+            <a:off x="9418320" y="3767328"/>
+            <a:ext cx="2221992" cy="640080"/>
+          </a:xfrm>
+          <a:prstGeom prst="rect">
+            <a:avLst/>
+          </a:prstGeom>
+          <a:noFill/>
+          <a:ln>
+            <a:noFill/>
+          </a:ln>
+        </p:spPr>
+        <p:txBody>
+          <a:bodyPr spcFirstLastPara="1" wrap="square" lIns="0" tIns="0" rIns="0" bIns="0" anchor="ctr" anchorCtr="0">
+            <a:noAutofit/>
+          </a:bodyPr>
+          <a:lstStyle/>
+          <a:p>
+            <a:pPr marL="0" marR="0" lvl="0" indent="0" algn="l" rtl="0">
+              <a:lnSpc>
+                <a:spcPct val="105000"/>
+              </a:lnSpc>
+              <a:spcBef>
+                <a:spcPts val="0"/>
+              </a:spcBef>
+              <a:spcAft>
+                <a:spcPts val="0"/>
+              </a:spcAft>
+              <a:buNone/>
+            </a:pPr>
+            <a:r>
+              <a:rPr lang="zh-CN" sz="1100" b="1" i="0" u="none" strike="noStrike" cap="none">
+                <a:solidFill>
+                  <a:srgbClr val="C2410C"/>
+                </a:solidFill>
+                <a:latin typeface="Instrument Sans"/>
+                <a:ea typeface="Instrument Sans"/>
+                <a:cs typeface="Instrument Sans"/>
+                <a:sym typeface="Instrument Sans"/>
+              </a:rPr>
+              <a:t>6个月：第2家授权</a:t>
+            </a:r>
+          </a:p>
+        </p:txBody>
+      </p:sp>
+      <p:sp>
+        <p:nvSpPr>
+          <p:cNvPr id="5030" name="SimReal 5030"/>
+          <p:cNvSpPr/>
+          <p:nvPr/>
+        </p:nvSpPr>
+        <p:spPr>
+          <a:xfrm>
+            <a:off x="548640" y="4407408"/>
+            <a:ext cx="11091672" cy="9144"/>
+          </a:xfrm>
+          <a:prstGeom prst="rect">
+            <a:avLst/>
+          </a:prstGeom>
+          <a:solidFill>
+            <a:srgbClr val="E2E0DA"/>
+          </a:solidFill>
+          <a:ln>
+            <a:noFill/>
+          </a:ln>
+        </p:spPr>
+        <p:txBody>
+          <a:bodyPr/>
+          <a:lstStyle/>
+          <a:p>
+            <a:endParaRPr/>
+          </a:p>
+        </p:txBody>
+      </p:sp>
+      <p:sp>
+        <p:nvSpPr>
+          <p:cNvPr id="5031" name="SimReal 5031"/>
+          <p:cNvSpPr txBox="1"/>
+          <p:nvPr/>
+        </p:nvSpPr>
+        <p:spPr>
+          <a:xfrm>
+            <a:off x="548640" y="4407408"/>
+            <a:ext cx="2103120" cy="640080"/>
+          </a:xfrm>
+          <a:prstGeom prst="rect">
+            <a:avLst/>
+          </a:prstGeom>
+          <a:noFill/>
+          <a:ln>
+            <a:noFill/>
+          </a:ln>
+        </p:spPr>
+        <p:txBody>
+          <a:bodyPr spcFirstLastPara="1" wrap="square" lIns="0" tIns="0" rIns="0" bIns="0" anchor="ctr" anchorCtr="0">
+            <a:noAutofit/>
+          </a:bodyPr>
+          <a:lstStyle/>
+          <a:p>
+            <a:pPr marL="0" marR="0" lvl="0" indent="0" algn="l" rtl="0">
+              <a:spcBef>
+                <a:spcPts val="0"/>
+              </a:spcBef>
+              <a:spcAft>
+                <a:spcPts val="0"/>
+              </a:spcAft>
+              <a:buNone/>
+            </a:pPr>
+            <a:r>
+              <a:rPr lang="zh-CN" sz="1500" b="0" i="0" u="none" strike="noStrike" cap="none">
                 <a:solidFill>
                   <a:srgbClr val="111110"/>
                 </a:solidFill>
@@ -37362,6 +39105,264 @@
                 <a:cs typeface="Newsreader"/>
                 <a:sym typeface="Newsreader"/>
               </a:rPr>
+              <a:t>跨境合规</a:t>
+            </a:r>
+          </a:p>
+        </p:txBody>
+      </p:sp>
+      <p:sp>
+        <p:nvSpPr>
+          <p:cNvPr id="5032" name="SimReal 5032"/>
+          <p:cNvSpPr txBox="1"/>
+          <p:nvPr/>
+        </p:nvSpPr>
+        <p:spPr>
+          <a:xfrm>
+            <a:off x="2743200" y="4407408"/>
+            <a:ext cx="3200400" cy="640080"/>
+          </a:xfrm>
+          <a:prstGeom prst="rect">
+            <a:avLst/>
+          </a:prstGeom>
+          <a:noFill/>
+          <a:ln>
+            <a:noFill/>
+          </a:ln>
+        </p:spPr>
+        <p:txBody>
+          <a:bodyPr spcFirstLastPara="1" wrap="square" lIns="0" tIns="0" rIns="0" bIns="0" anchor="ctr" anchorCtr="0">
+            <a:noAutofit/>
+          </a:bodyPr>
+          <a:lstStyle/>
+          <a:p>
+            <a:pPr marL="0" marR="0" lvl="0" indent="0" algn="l" rtl="0">
+              <a:lnSpc>
+                <a:spcPct val="105000"/>
+              </a:lnSpc>
+              <a:spcBef>
+                <a:spcPts val="0"/>
+              </a:spcBef>
+              <a:spcAft>
+                <a:spcPts val="0"/>
+              </a:spcAft>
+              <a:buNone/>
+            </a:pPr>
+            <a:r>
+              <a:rPr lang="zh-CN" sz="1100" b="0" i="0" u="none" strike="noStrike" cap="none">
+                <a:solidFill>
+                  <a:srgbClr val="33322F"/>
+                </a:solidFill>
+                <a:latin typeface="Instrument Sans"/>
+                <a:ea typeface="Instrument Sans"/>
+                <a:cs typeface="Instrument Sans"/>
+                <a:sym typeface="Instrument Sans"/>
+              </a:rPr>
+              <a:t>中国团队，服务中美实验室</a:t>
+            </a:r>
+          </a:p>
+        </p:txBody>
+      </p:sp>
+      <p:sp>
+        <p:nvSpPr>
+          <p:cNvPr id="5033" name="SimReal 5033"/>
+          <p:cNvSpPr txBox="1"/>
+          <p:nvPr/>
+        </p:nvSpPr>
+        <p:spPr>
+          <a:xfrm>
+            <a:off x="6080760" y="4407408"/>
+            <a:ext cx="3200400" cy="640080"/>
+          </a:xfrm>
+          <a:prstGeom prst="rect">
+            <a:avLst/>
+          </a:prstGeom>
+          <a:noFill/>
+          <a:ln>
+            <a:noFill/>
+          </a:ln>
+        </p:spPr>
+        <p:txBody>
+          <a:bodyPr spcFirstLastPara="1" wrap="square" lIns="0" tIns="0" rIns="0" bIns="0" anchor="ctr" anchorCtr="0">
+            <a:noAutofit/>
+          </a:bodyPr>
+          <a:lstStyle/>
+          <a:p>
+            <a:pPr marL="0" marR="0" lvl="0" indent="0" algn="l" rtl="0">
+              <a:lnSpc>
+                <a:spcPct val="105000"/>
+              </a:lnSpc>
+              <a:spcBef>
+                <a:spcPts val="0"/>
+              </a:spcBef>
+              <a:spcAft>
+                <a:spcPts val="0"/>
+              </a:spcAft>
+              <a:buNone/>
+            </a:pPr>
+            <a:r>
+              <a:rPr lang="zh-CN" sz="1100" b="0" i="0" u="none" strike="noStrike" cap="none">
+                <a:solidFill>
+                  <a:srgbClr val="33322F"/>
+                </a:solidFill>
+                <a:latin typeface="Instrument Sans"/>
+                <a:ea typeface="Instrument Sans"/>
+                <a:cs typeface="Instrument Sans"/>
+                <a:sym typeface="Instrument Sans"/>
+              </a:rPr>
+              <a:t>数据按客户所在地区分开存储与交付</a:t>
+            </a:r>
+          </a:p>
+        </p:txBody>
+      </p:sp>
+      <p:sp>
+        <p:nvSpPr>
+          <p:cNvPr id="5034" name="SimReal 5034"/>
+          <p:cNvSpPr txBox="1"/>
+          <p:nvPr/>
+        </p:nvSpPr>
+        <p:spPr>
+          <a:xfrm>
+            <a:off x="9418320" y="4407408"/>
+            <a:ext cx="2221992" cy="640080"/>
+          </a:xfrm>
+          <a:prstGeom prst="rect">
+            <a:avLst/>
+          </a:prstGeom>
+          <a:noFill/>
+          <a:ln>
+            <a:noFill/>
+          </a:ln>
+        </p:spPr>
+        <p:txBody>
+          <a:bodyPr spcFirstLastPara="1" wrap="square" lIns="0" tIns="0" rIns="0" bIns="0" anchor="ctr" anchorCtr="0">
+            <a:noAutofit/>
+          </a:bodyPr>
+          <a:lstStyle/>
+          <a:p>
+            <a:pPr marL="0" marR="0" lvl="0" indent="0" algn="l" rtl="0">
+              <a:lnSpc>
+                <a:spcPct val="105000"/>
+              </a:lnSpc>
+              <a:spcBef>
+                <a:spcPts val="0"/>
+              </a:spcBef>
+              <a:spcAft>
+                <a:spcPts val="0"/>
+              </a:spcAft>
+              <a:buNone/>
+            </a:pPr>
+            <a:r>
+              <a:rPr lang="zh-CN" sz="1100" b="1" i="0" u="none" strike="noStrike" cap="none">
+                <a:solidFill>
+                  <a:srgbClr val="C2410C"/>
+                </a:solidFill>
+                <a:latin typeface="Instrument Sans"/>
+                <a:ea typeface="Instrument Sans"/>
+                <a:cs typeface="Instrument Sans"/>
+                <a:sym typeface="Instrument Sans"/>
+              </a:rPr>
+              <a:t>【待补：主体与架构】</a:t>
+            </a:r>
+          </a:p>
+        </p:txBody>
+      </p:sp>
+      <p:sp>
+        <p:nvSpPr>
+          <p:cNvPr id="5035" name="SimReal 5035"/>
+          <p:cNvSpPr/>
+          <p:nvPr/>
+        </p:nvSpPr>
+        <p:spPr>
+          <a:xfrm>
+            <a:off x="548640" y="5047488"/>
+            <a:ext cx="11091672" cy="9144"/>
+          </a:xfrm>
+          <a:prstGeom prst="rect">
+            <a:avLst/>
+          </a:prstGeom>
+          <a:solidFill>
+            <a:srgbClr val="E2E0DA"/>
+          </a:solidFill>
+          <a:ln>
+            <a:noFill/>
+          </a:ln>
+        </p:spPr>
+        <p:txBody>
+          <a:bodyPr/>
+          <a:lstStyle/>
+          <a:p>
+            <a:endParaRPr/>
+          </a:p>
+        </p:txBody>
+      </p:sp>
+      <p:sp>
+        <p:nvSpPr>
+          <p:cNvPr id="5036" name="SimReal 5036"/>
+          <p:cNvSpPr txBox="1"/>
+          <p:nvPr/>
+        </p:nvSpPr>
+        <p:spPr>
+          <a:xfrm>
+            <a:off x="548640" y="5349240"/>
+            <a:ext cx="11091672" cy="420624"/>
+          </a:xfrm>
+          <a:prstGeom prst="rect">
+            <a:avLst/>
+          </a:prstGeom>
+          <a:noFill/>
+          <a:ln>
+            <a:noFill/>
+          </a:ln>
+        </p:spPr>
+        <p:txBody>
+          <a:bodyPr spcFirstLastPara="1" wrap="square" lIns="0" tIns="0" rIns="0" bIns="0" anchor="ctr" anchorCtr="0">
+            <a:noAutofit/>
+          </a:bodyPr>
+          <a:lstStyle/>
+          <a:p>
+            <a:pPr marL="0" marR="0" lvl="0" indent="0" algn="l" rtl="0">
+              <a:spcBef>
+                <a:spcPts val="0"/>
+              </a:spcBef>
+              <a:spcAft>
+                <a:spcPts val="0"/>
+              </a:spcAft>
+              <a:buNone/>
+            </a:pPr>
+            <a:r>
+              <a:rPr lang="zh-CN" sz="2000" b="0" i="0" u="none" strike="noStrike" cap="none">
+                <a:solidFill>
+                  <a:srgbClr val="111110"/>
+                </a:solidFill>
+                <a:latin typeface="Newsreader"/>
+                <a:ea typeface="Newsreader"/>
+                <a:cs typeface="Newsreader"/>
+                <a:sym typeface="Newsreader"/>
+              </a:rPr>
+              <a:t>不过度美化：</a:t>
+            </a:r>
+            <a:r>
+              <a:rPr lang="zh-CN" sz="2000" b="0" i="0" u="none" strike="noStrike" cap="none">
+                <a:solidFill>
+                  <a:srgbClr val="C2410C"/>
+                </a:solidFill>
+                <a:latin typeface="Newsreader"/>
+                <a:ea typeface="Newsreader"/>
+                <a:cs typeface="Newsreader"/>
+                <a:sym typeface="Newsreader"/>
+              </a:rPr>
+              <a:t>每个数字都能在尽调里复现</a:t>
+            </a:r>
+            <a:r>
+              <a:rPr lang="zh-CN" sz="2000" b="0" i="0" u="none" strike="noStrike" cap="none">
+                <a:solidFill>
+                  <a:srgbClr val="111110"/>
+                </a:solidFill>
+                <a:latin typeface="Newsreader"/>
+                <a:ea typeface="Newsreader"/>
+                <a:cs typeface="Newsreader"/>
+                <a:sym typeface="Newsreader"/>
+              </a:rPr>
               <a:t>。</a:t>
             </a:r>
           </a:p>
@@ -37509,7 +39510,7 @@
                 <a:cs typeface="IBM Plex Mono"/>
                 <a:sym typeface="IBM Plex Mono"/>
               </a:rPr>
-              <a:t>20</a:t>
+              <a:t>21</a:t>
             </a:r>
           </a:p>
         </p:txBody>
@@ -39375,7 +41376,7 @@
                 <a:cs typeface="IBM Plex Mono"/>
                 <a:sym typeface="IBM Plex Mono"/>
               </a:rPr>
-              <a:t>11</a:t>
+              <a:t>12</a:t>
             </a:r>
           </a:p>
         </p:txBody>
@@ -41210,7 +43211,7 @@
                 <a:cs typeface="IBM Plex Mono"/>
                 <a:sym typeface="IBM Plex Mono"/>
               </a:rPr>
-              <a:t>11</a:t>
+              <a:t>12</a:t>
             </a:r>
           </a:p>
         </p:txBody>

</xml_diff>